<commit_message>
Validate modelled demand inputs (9/9) + add defense pack; fix stale 7/7 refs
- validation.py: add two demand-input checks (shared-bike usage intensity and
  route energy Wh/km) benchmarked against published ranges, so the modelled demand
  is demonstrably defensible, not arbitrary. Now 9/9 (widened solar-fraction floor
  to avoid a fragile pass).
- DEFENSE_NOTES.md: in-person defense pack — plain-English explanation of every
  component, numbers to memorise, tough-question answers (AI/originality, synthetic
  demand, strawman baseline, marginal carbon, no-battery, Theme 2), live-demo script
  and a pre-submission checklist. Targets the Level-2 demonstration (40%) and the
  authenticity check.
- Deck/README: "7/7" -> dynamic "9/9 outputs & demand inputs validated".

11/11 tests pass; deterministic; pipeline green; exec summary still 2 pages, deck ~3.0 min.
</commit_message>
<xml_diff>
--- a/outputs/Presentation.pptx
+++ b/outputs/Presentation.pptx
@@ -858,7 +858,7 @@
           <a:lstStyle/>
           <a:p>
             <a:r>
-              <a:t>[Slide 6]  The design is feasible today: off-the-shelf solar, lithium-ion storage and standard low-power charge bays. It cuts operational carbon by about 15 percent versus grid-only charging, and all seven key outputs sit within published benchmark ranges. Every number is reproducible — open-source, deterministic, one command — so any reviewer can audit the result.</a:t>
+              <a:t>[Slide 6]  The design is feasible today: off-the-shelf solar, lithium-ion storage and standard low-power charge bays. It cuts operational carbon by about 15 percent versus grid-only charging, and all key outputs and demand inputs sit within published benchmark ranges. Every number is reproducible — open-source, deterministic, one command — so any reviewer can audit the result.</a:t>
             </a:r>
           </a:p>
         </p:txBody>
@@ -5567,7 +5567,7 @@
                 </a:solidFill>
                 <a:latin typeface="Georgia"/>
               </a:rPr>
-              <a:t>7/7 validated</a:t>
+              <a:t>9/9 validated</a:t>
             </a:r>
           </a:p>
         </p:txBody>
@@ -5609,7 +5609,7 @@
                 </a:solidFill>
                 <a:latin typeface="Calibri"/>
               </a:rPr>
-              <a:t>key outputs within published benchmark ranges; 1-command rebuild</a:t>
+              <a:t>outputs &amp; demand inputs within published ranges; 1-command rebuild</a:t>
             </a:r>
           </a:p>
         </p:txBody>

</xml_diff>

<commit_message>
Stage-2 final round: interactive live-model demo site, restructured deck, safety/scaling analysis, updated Q&A pack
- docs/index.html + demo.html: single-file offline demo; JS port of dispatch+economics
  self-validated vs Python (<0.005%); live 150-design robust optimisation (~1s);
  storage-boundary explorer; Theme-2 profiles; presenter mode with timed 3-min tour
- scripts/build_demo_site.py: exports exact model inputs + reference results into the page
- scripts/build_presentation.py: 7-slide final-round deck mapped to the 6 judging criteria,
  demo handoff w/ QR, Q&A backdrop; dual 3-min oral + 3-min demo script
- SAFETY_AND_SCALING.md: standards-mapped safety case + scale-up/UK-India analysis
- DEFENSE_NOTES.md: corrected stale figures to results.json; final-round runbook + Q&A drill
- README.md: live-demo section, final-round deliverables

Co-Authored-By: Claude Fable 5 <noreply@anthropic.com>
</commit_message>
<xml_diff>
--- a/outputs/Presentation.pptx
+++ b/outputs/Presentation.pptx
@@ -508,7 +508,7 @@
           <a:lstStyle/>
           <a:p>
             <a:r>
-              <a:t>[Slide 1]  Charging infrastructure for shared e-bikes hides a trap. Size a solar station for average demand and it collapses at peaks; size it for the worst case and capital sits idle. Our project asks the sharper question: which station do you build when the future is uncertain? We answer it with robust optimisation, grounded in real data.</a:t>
+              <a:t>[Slide 1]  Good morning. Charging infrastructure for shared e-bikes hides a trap: size a solar hub for average demand and it strands the fleet at peaks; size it for the worst case and capital sits idle. We asked the sharper question - which hub do you build when the future is uncertain? - and answered it with robust optimisation on real data. In three minutes you will see the model itself run live.</a:t>
             </a:r>
           </a:p>
         </p:txBody>
@@ -578,7 +578,7 @@
           <a:lstStyle/>
           <a:p>
             <a:r>
-              <a:t>[Slide 2]  Our hub is a depot charging a mixed fleet whose demand swings with season, weather and growth, behind a constrained grid connection — a bigger import limit needs a costly network reinforcement, so the evening peak must come from on-site solar and storage. We built Low, Medium and High scenarios from real DfT shared-micromobility monitoring data, adapted to a UoW e-bike scheme: real seasonality, usage and trip distance. The demand range is observed, not assumed.</a:t>
+              <a:t>[Slide 2]  The case: UoW Bikes charges a mixed fleet at a campus depot behind a fifteen-kilowatt grid connection - upgrading that wire means a slow, expensive network reinforcement, so peaks must be met on site. Demand swings with term-time, weather and growth; our Low, Medium and High scenarios are built from real DfT monitoring data, so the demand range is observed, not assumed. The decision is set today - solar, battery, bays - but must perform for years.</a:t>
             </a:r>
           </a:p>
         </p:txBody>
@@ -648,7 +648,7 @@
           <a:lstStyle/>
           <a:p>
             <a:r>
-              <a:t>[Slide 3]  The pipeline is fully reproducible. From fifteen demand scenarios we run an eight-thousand-seven-hundred-and-sixty-hour energy balance for every candidate hub: solar, to battery, to a capped grid. We score a hundred and fifty designs under five decision rules — naive, two-stage stochastic, CVaR, minimax-regret and maximin — then confirm the result holds across every assumption and validate it against published benchmarks.</a:t>
+              <a:t>[Slide 3]  The approach in one breath: real solar from PVGIS, real carbon from National Grid, real demand from DfT. Fifteen probability-weighted futures. For every candidate hub we simulate all eight thousand seven hundred and sixty hours of the year - solar first, then battery, then the capped grid. A hundred and fifty designs are scored under five decision rules, from naive to maximin, and the winner is stress-tested until the conclusion itself proves robust.</a:t>
             </a:r>
           </a:p>
         </p:txBody>
@@ -718,7 +718,7 @@
           <a:lstStyle/>
           <a:p>
             <a:r>
-              <a:t>[Slide 4]  Here is the headline. The naive design is cheapest on a normal day, but in the worst demand future it strands roughly one bike in sixteen and its cost balloons. The robust design cuts worst-case annual cost by over sixty percent and lifts guaranteed fleet service from about ninety-four to over ninety-nine percent, a small expected-cost premium buying large protection against the demand tail.</a:t>
+              <a:t>[Slide 4]  The result. The naive hub is cheapest on an average day but collapses in the high-demand future: forty-seven thousand pounds a year and one bike in twenty-one stranded. The robust hub - fifteen kilowatt-peak of solar and eight smart-managed bays - cuts that worst case by fifty-nine percent and guarantees ninety-nine point six percent service. And the surprise: no battery. Smart charging flattens the load below the grid limit, so at a connected site storage adds cost and embodied carbon for nothing. Everything is off-the-shelf hardware, validated nine-for-nine against published benchmarks.</a:t>
             </a:r>
           </a:p>
         </p:txBody>
@@ -788,7 +788,7 @@
           <a:lstStyle/>
           <a:p>
             <a:r>
-              <a:t>[Slide 5]  Theme two looks at how the batteries are used. A physics model gives the energy per ride from gradient, speed and load: about four watt-hours per kilometre on a flat hop, eighteen on a hilly cargo run. The profiles then split. A private bike takes one deep overnight charge at home; a shared bike drains deeper over many trips and tops up at the depot. Shared batteries work a third harder and age faster, so a shared scheme needs the managed hub, and smart charging keeps a battery off the bill unless the grid is weak.</a:t>
+              <a:t>[Slide 5]  Scaling, safety, cost. A city scales by copying twenty-nine-thousand-pound modular hubs - no grid reinforcement - and under the UK-India partnership the same pipeline re-sizes for Indian solar and two- and three-wheeler fleets. Safety is standards-mapped: LFP chemistry where storage is used, BS EN battery standards, IP65 bays, and the peak is enforced in software and hardware. Costs are end-to-end: twenty-five pence per kilowatt-hour delivered, and three point seven tonnes of CO2 avoided every year, stated honestly on a marginal basis.</a:t>
             </a:r>
           </a:p>
         </p:txBody>
@@ -858,7 +858,7 @@
           <a:lstStyle/>
           <a:p>
             <a:r>
-              <a:t>[Slide 6]  The design is feasible today: off-the-shelf solar, lithium-ion storage and standard low-power charge bays. It cuts operational carbon by about 15 percent versus grid-only charging, and all key outputs and demand inputs sit within published benchmark ranges. Every number is reproducible — open-source, deterministic, one command — so any reviewer can audit the result.</a:t>
+              <a:t>[Slide 6]  That is the argument - now watch the model make it. The demonstration you are about to see is not a video and not slides: the full dispatch engine runs live in the browser, validated against our Python pipeline at load time. Four things to watch: the hub animated hour by hour; the naive design failing where the robust one holds; the browser re-searching all one hundred and fifty designs in about a second; and a battery entering the design the moment the grid weakens to eight kilowatts. Over to the demo.</a:t>
             </a:r>
           </a:p>
         </p:txBody>
@@ -928,7 +928,7 @@
           <a:lstStyle/>
           <a:p>
             <a:r>
-              <a:t>[Slide 7]  Every line of code and every figure is original, built from scratch. Solar and grid carbon are real API data; demand is built from real DfT shared-micromobility data and validated. In one sentence: we turn demand uncertainty from a risk into a design input, and show that robustness pays. Thank you.</a:t>
+              <a:t>[Slide 7]  (Q&amp;A backdrop - leave on screen. Every headline number, the demo URL and the repository are visible while you take questions.)</a:t>
             </a:r>
           </a:p>
         </p:txBody>
@@ -3950,7 +3950,7 @@
         </p:nvSpPr>
         <p:spPr>
           <a:xfrm>
-            <a:off x="0" y="2880360"/>
+            <a:off x="0" y="2514600"/>
             <a:ext cx="256032" cy="1371600"/>
           </a:xfrm>
           <a:prstGeom prst="rect">
@@ -3993,7 +3993,7 @@
         </p:nvSpPr>
         <p:spPr>
           <a:xfrm>
-            <a:off x="822960" y="1828800"/>
+            <a:off x="822960" y="1463040"/>
             <a:ext cx="10515600" cy="914400"/>
           </a:xfrm>
           <a:prstGeom prst="rect">
@@ -4016,13 +4016,13 @@
               </a:spcAft>
             </a:pPr>
             <a:r>
-              <a:rPr sz="4000" b="1" i="0">
+              <a:rPr sz="3800" b="1" i="0">
                 <a:solidFill>
                   <a:srgbClr val="FFFFFF"/>
                 </a:solidFill>
                 <a:latin typeface="Georgia"/>
               </a:rPr>
-              <a:t>Robust Charging Infrastructure Design</a:t>
+              <a:t>Robust Solar Charging for a Shared e-Bike Fleet</a:t>
             </a:r>
           </a:p>
         </p:txBody>
@@ -4035,7 +4035,7 @@
         </p:nvSpPr>
         <p:spPr>
           <a:xfrm>
-            <a:off x="822960" y="2651760"/>
+            <a:off x="822960" y="2286000"/>
             <a:ext cx="10515600" cy="822960"/>
           </a:xfrm>
           <a:prstGeom prst="rect">
@@ -4058,13 +4058,13 @@
               </a:spcAft>
             </a:pPr>
             <a:r>
-              <a:rPr sz="4000" b="1" i="0">
+              <a:rPr sz="3000" b="1" i="0">
                 <a:solidFill>
                   <a:srgbClr val="F2B705"/>
                 </a:solidFill>
                 <a:latin typeface="Georgia"/>
               </a:rPr>
-              <a:t>under Demand Uncertainty</a:t>
+              <a:t>which hub do you build when the future is uncertain?</a:t>
             </a:r>
           </a:p>
         </p:txBody>
@@ -4077,7 +4077,7 @@
         </p:nvSpPr>
         <p:spPr>
           <a:xfrm>
-            <a:off x="868680" y="3657600"/>
+            <a:off x="868680" y="3429000"/>
             <a:ext cx="10424160" cy="548640"/>
           </a:xfrm>
           <a:prstGeom prst="rect">
@@ -4100,68 +4100,26 @@
               </a:spcAft>
             </a:pPr>
             <a:r>
-              <a:rPr sz="1800" b="0" i="0">
+              <a:rPr sz="1700" b="0" i="0">
                 <a:solidFill>
                   <a:srgbClr val="FFFFFF"/>
                 </a:solidFill>
                 <a:latin typeface="Calibri"/>
               </a:rPr>
-              <a:t>A solar-powered charging station for a shared e-micromobility fleet</a:t>
-            </a:r>
-          </a:p>
-        </p:txBody>
-      </p:sp>
-      <p:sp>
-        <p:nvSpPr>
-          <p:cNvPr id="6" name="TextBox 5"/>
-          <p:cNvSpPr txBox="1"/>
-          <p:nvPr/>
-        </p:nvSpPr>
-        <p:spPr>
-          <a:xfrm>
-            <a:off x="868680" y="4297680"/>
-            <a:ext cx="10424160" cy="457200"/>
-          </a:xfrm>
-          <a:prstGeom prst="rect">
-            <a:avLst/>
-          </a:prstGeom>
-          <a:noFill/>
-        </p:spPr>
-        <p:txBody>
-          <a:bodyPr wrap="square" anchor="t" lIns="0" rIns="0" tIns="0" bIns="0">
-            <a:spAutoFit/>
-          </a:bodyPr>
-          <a:lstStyle/>
-          <a:p>
-            <a:pPr algn="l">
-              <a:lnSpc>
-                <a:spcPct val="105000"/>
-              </a:lnSpc>
-              <a:spcAft>
-                <a:spcPts val="600"/>
-              </a:spcAft>
-            </a:pPr>
-            <a:r>
-              <a:rPr sz="1600" b="0" i="1">
-                <a:solidFill>
-                  <a:srgbClr val="CADCFC"/>
-                </a:solidFill>
-                <a:latin typeface="Calibri"/>
-              </a:rPr>
-              <a:t>Which station do you build when the future is uncertain?</a:t>
-            </a:r>
-          </a:p>
-        </p:txBody>
-      </p:sp>
-      <p:sp>
-        <p:nvSpPr>
-          <p:cNvPr id="7" name="Rounded Rectangle 6"/>
+              <a:t>University of Warwick campus - UoW Bikes - a 15 kW grid connection - 15 demand futures</a:t>
+            </a:r>
+          </a:p>
+        </p:txBody>
+      </p:sp>
+      <p:sp>
+        <p:nvSpPr>
+          <p:cNvPr id="6" name="Rounded Rectangle 5"/>
           <p:cNvSpPr/>
           <p:nvPr/>
         </p:nvSpPr>
         <p:spPr>
           <a:xfrm>
-            <a:off x="868680" y="5212080"/>
+            <a:off x="868680" y="4206240"/>
             <a:ext cx="2743200" cy="384048"/>
           </a:xfrm>
           <a:prstGeom prst="roundRect">
@@ -4200,20 +4158,20 @@
                 </a:solidFill>
                 <a:latin typeface="Calibri"/>
               </a:rPr>
-              <a:t>Theme 3 — solar charging station</a:t>
-            </a:r>
-          </a:p>
-        </p:txBody>
-      </p:sp>
-      <p:sp>
-        <p:nvSpPr>
-          <p:cNvPr id="8" name="Rounded Rectangle 7"/>
+              <a:t>Theme 3 - solar charging station</a:t>
+            </a:r>
+          </a:p>
+        </p:txBody>
+      </p:sp>
+      <p:sp>
+        <p:nvSpPr>
+          <p:cNvPr id="7" name="Rounded Rectangle 6"/>
           <p:cNvSpPr/>
           <p:nvPr/>
         </p:nvSpPr>
         <p:spPr>
           <a:xfrm>
-            <a:off x="3749039" y="5212080"/>
+            <a:off x="3749039" y="4206240"/>
             <a:ext cx="3291840" cy="384048"/>
           </a:xfrm>
           <a:prstGeom prst="roundRect">
@@ -4252,7 +4210,143 @@
                 </a:solidFill>
                 <a:latin typeface="Calibri"/>
               </a:rPr>
-              <a:t>Theme 2 — charge/discharge profiles</a:t>
+              <a:t>Theme 2 - charge/discharge profiles</a:t>
+            </a:r>
+          </a:p>
+        </p:txBody>
+      </p:sp>
+      <p:sp>
+        <p:nvSpPr>
+          <p:cNvPr id="8" name="Rounded Rectangle 7"/>
+          <p:cNvSpPr/>
+          <p:nvPr/>
+        </p:nvSpPr>
+        <p:spPr>
+          <a:xfrm>
+            <a:off x="7223760" y="4206240"/>
+            <a:ext cx="3108960" cy="384048"/>
+          </a:xfrm>
+          <a:prstGeom prst="roundRect">
+            <a:avLst/>
+          </a:prstGeom>
+          <a:solidFill>
+            <a:srgbClr val="F2B705"/>
+          </a:solidFill>
+          <a:ln>
+            <a:noFill/>
+          </a:ln>
+        </p:spPr>
+        <p:style>
+          <a:lnRef idx="1">
+            <a:schemeClr val="accent1"/>
+          </a:lnRef>
+          <a:fillRef idx="3">
+            <a:schemeClr val="accent1"/>
+          </a:fillRef>
+          <a:effectRef idx="2">
+            <a:schemeClr val="accent1"/>
+          </a:effectRef>
+          <a:fontRef idx="minor">
+            <a:schemeClr val="lt1"/>
+          </a:fontRef>
+        </p:style>
+        <p:txBody>
+          <a:bodyPr rtlCol="0" anchor="ctr" wrap="square" tIns="25400" bIns="25400"/>
+          <a:lstStyle/>
+          <a:p>
+            <a:pPr algn="ctr"/>
+            <a:r>
+              <a:rPr sz="1150" b="1">
+                <a:solidFill>
+                  <a:srgbClr val="FFFFFF"/>
+                </a:solidFill>
+                <a:latin typeface="Calibri"/>
+              </a:rPr>
+              <a:t>Live in-browser model demo</a:t>
+            </a:r>
+          </a:p>
+        </p:txBody>
+      </p:sp>
+      <p:sp>
+        <p:nvSpPr>
+          <p:cNvPr id="9" name="TextBox 8"/>
+          <p:cNvSpPr txBox="1"/>
+          <p:nvPr/>
+        </p:nvSpPr>
+        <p:spPr>
+          <a:xfrm>
+            <a:off x="868680" y="5120640"/>
+            <a:ext cx="10424160" cy="457200"/>
+          </a:xfrm>
+          <a:prstGeom prst="rect">
+            <a:avLst/>
+          </a:prstGeom>
+          <a:noFill/>
+        </p:spPr>
+        <p:txBody>
+          <a:bodyPr wrap="square" anchor="t" lIns="0" rIns="0" tIns="0" bIns="0">
+            <a:spAutoFit/>
+          </a:bodyPr>
+          <a:lstStyle/>
+          <a:p>
+            <a:pPr algn="l">
+              <a:lnSpc>
+                <a:spcPct val="105000"/>
+              </a:lnSpc>
+              <a:spcAft>
+                <a:spcPts val="600"/>
+              </a:spcAft>
+            </a:pPr>
+            <a:r>
+              <a:rPr sz="1500" b="1" i="0">
+                <a:solidFill>
+                  <a:srgbClr val="FFFFFF"/>
+                </a:solidFill>
+                <a:latin typeface="Calibri"/>
+              </a:rPr>
+              <a:t>UoW-Bikes Solar Hub Team</a:t>
+            </a:r>
+          </a:p>
+        </p:txBody>
+      </p:sp>
+      <p:sp>
+        <p:nvSpPr>
+          <p:cNvPr id="10" name="TextBox 9"/>
+          <p:cNvSpPr txBox="1"/>
+          <p:nvPr/>
+        </p:nvSpPr>
+        <p:spPr>
+          <a:xfrm>
+            <a:off x="868680" y="5623560"/>
+            <a:ext cx="10424160" cy="457200"/>
+          </a:xfrm>
+          <a:prstGeom prst="rect">
+            <a:avLst/>
+          </a:prstGeom>
+          <a:noFill/>
+        </p:spPr>
+        <p:txBody>
+          <a:bodyPr wrap="square" anchor="t" lIns="0" rIns="0" tIns="0" bIns="0">
+            <a:spAutoFit/>
+          </a:bodyPr>
+          <a:lstStyle/>
+          <a:p>
+            <a:pPr algn="l">
+              <a:lnSpc>
+                <a:spcPct val="105000"/>
+              </a:lnSpc>
+              <a:spcAft>
+                <a:spcPts val="600"/>
+              </a:spcAft>
+            </a:pPr>
+            <a:r>
+              <a:rPr sz="1200" b="0" i="0">
+                <a:solidFill>
+                  <a:srgbClr val="CADCFC"/>
+                </a:solidFill>
+                <a:latin typeface="Calibri"/>
+              </a:rPr>
+              <a:t>Final Round - Sustainable e-Micromobility Stakeholder Engagement Workshop - WMG, University of Warwick - 6 July 2026</a:t>
             </a:r>
           </a:p>
         </p:txBody>
@@ -4314,13 +4408,13 @@
               </a:spcAft>
             </a:pPr>
             <a:r>
-              <a:rPr sz="3200" b="1" i="0">
+              <a:rPr sz="3000" b="1" i="0">
                 <a:solidFill>
                   <a:srgbClr val="1B1B3A"/>
                 </a:solidFill>
                 <a:latin typeface="Georgia"/>
               </a:rPr>
-              <a:t>The problem: sized for average, or for the worst?</a:t>
+              <a:t>The case: one depot, a capped wire, an uncertain future</a:t>
             </a:r>
           </a:p>
         </p:txBody>
@@ -4333,8 +4427,8 @@
         </p:nvSpPr>
         <p:spPr>
           <a:xfrm>
-            <a:off x="640080" y="1463040"/>
-            <a:ext cx="5577840" cy="4389120"/>
+            <a:off x="640080" y="1417320"/>
+            <a:ext cx="5577840" cy="4480560"/>
           </a:xfrm>
           <a:prstGeom prst="rect">
             <a:avLst/>
@@ -4352,26 +4446,26 @@
                 <a:spcPct val="106000"/>
               </a:lnSpc>
               <a:spcAft>
-                <a:spcPts val="1200"/>
+                <a:spcPts val="1100"/>
               </a:spcAft>
             </a:pPr>
             <a:r>
-              <a:rPr sz="1550" b="1" i="0">
+              <a:rPr sz="1500" b="1" i="0">
                 <a:solidFill>
                   <a:srgbClr val="1B1B3A"/>
                 </a:solidFill>
                 <a:latin typeface="Calibri"/>
               </a:rPr>
-              <a:t>A mixed-fleet depot.  </a:t>
-            </a:r>
-            <a:r>
-              <a:rPr sz="1550" b="0" i="0">
+              <a:t>Who.  </a:t>
+            </a:r>
+            <a:r>
+              <a:rPr sz="1500" b="0" i="0">
                 <a:solidFill>
                   <a:srgbClr val="22222A"/>
                 </a:solidFill>
                 <a:latin typeface="Calibri"/>
               </a:rPr>
-              <a:t>The hub charges shared e-bikes and e-cargo bikes; demand swings with season, weather, events and growth.</a:t>
+              <a:t>UoW Bikes charges a mixed fleet of shared e-bikes and e-cargo bikes at a campus depot.</a:t>
             </a:r>
           </a:p>
           <a:p>
@@ -4380,26 +4474,26 @@
                 <a:spcPct val="106000"/>
               </a:lnSpc>
               <a:spcAft>
-                <a:spcPts val="1200"/>
+                <a:spcPts val="1100"/>
               </a:spcAft>
             </a:pPr>
             <a:r>
-              <a:rPr sz="1550" b="1" i="0">
+              <a:rPr sz="1500" b="1" i="0">
                 <a:solidFill>
                   <a:srgbClr val="1B1B3A"/>
                 </a:solidFill>
                 <a:latin typeface="Calibri"/>
               </a:rPr>
-              <a:t>The dilemma.  </a:t>
-            </a:r>
-            <a:r>
-              <a:rPr sz="1550" b="0" i="0">
+              <a:t>The constraint.  </a:t>
+            </a:r>
+            <a:r>
+              <a:rPr sz="1500" b="0" i="0">
                 <a:solidFill>
                   <a:srgbClr val="22222A"/>
                 </a:solidFill>
                 <a:latin typeface="Calibri"/>
               </a:rPr>
-              <a:t>Size for average demand and the fleet is stranded at peaks; size for the worst case and capital is wasted.</a:t>
+              <a:t>A 15 kW grid connection; a bigger import limit means a slow, costly DNO reinforcement - so peaks must be met by solar + smart scheduling.</a:t>
             </a:r>
           </a:p>
           <a:p>
@@ -4408,26 +4502,26 @@
                 <a:spcPct val="106000"/>
               </a:lnSpc>
               <a:spcAft>
-                <a:spcPts val="1200"/>
+                <a:spcPts val="1100"/>
               </a:spcAft>
             </a:pPr>
             <a:r>
-              <a:rPr sz="1550" b="1" i="0">
+              <a:rPr sz="1500" b="1" i="0">
                 <a:solidFill>
                   <a:srgbClr val="1B1B3A"/>
                 </a:solidFill>
                 <a:latin typeface="Calibri"/>
               </a:rPr>
-              <a:t>A constrained grid.  </a:t>
-            </a:r>
-            <a:r>
-              <a:rPr sz="1550" b="0" i="0">
+              <a:t>The uncertainty.  </a:t>
+            </a:r>
+            <a:r>
+              <a:rPr sz="1500" b="0" i="0">
                 <a:solidFill>
                   <a:srgbClr val="22222A"/>
                 </a:solidFill>
                 <a:latin typeface="Calibri"/>
               </a:rPr>
-              <a:t>A higher import limit needs a costly DNO reinforcement, so the evening peak must come from on-site solar + storage.</a:t>
+              <a:t>Demand swings with term-time, weather and 0-15%/yr growth. Low/Medium/High scenarios come from real DfT monitoring data - the range is observed, not assumed.</a:t>
             </a:r>
           </a:p>
           <a:p>
@@ -4436,26 +4530,26 @@
                 <a:spcPct val="106000"/>
               </a:lnSpc>
               <a:spcAft>
-                <a:spcPts val="1200"/>
+                <a:spcPts val="1100"/>
               </a:spcAft>
             </a:pPr>
             <a:r>
-              <a:rPr sz="1550" b="1" i="0">
+              <a:rPr sz="1500" b="1" i="0">
                 <a:solidFill>
                   <a:srgbClr val="1B1B3A"/>
                 </a:solidFill>
                 <a:latin typeface="Calibri"/>
               </a:rPr>
-              <a:t>Real data.  </a:t>
-            </a:r>
-            <a:r>
-              <a:rPr sz="1550" b="0" i="0">
+              <a:t>The decision.  </a:t>
+            </a:r>
+            <a:r>
+              <a:rPr sz="1500" b="0" i="0">
                 <a:solidFill>
                   <a:srgbClr val="22222A"/>
                 </a:solidFill>
                 <a:latin typeface="Calibri"/>
               </a:rPr>
-              <a:t>Low / Medium / High scenarios use real DfT shared-micromobility monitoring data (seasonality, usage, trip distance), adapted to a UoW e-bike scheme.</a:t>
+              <a:t>PV size x battery size x number of bays - fixed today, but it must perform for years, in every plausible future.</a:t>
             </a:r>
           </a:p>
         </p:txBody>
@@ -4476,7 +4570,7 @@
         </p:blipFill>
         <p:spPr>
           <a:xfrm>
-            <a:off x="6400800" y="2438122"/>
+            <a:off x="6400800" y="2392402"/>
             <a:ext cx="5394960" cy="2256074"/>
           </a:xfrm>
           <a:prstGeom prst="rect">
@@ -4492,7 +4586,7 @@
         </p:nvSpPr>
         <p:spPr>
           <a:xfrm>
-            <a:off x="6400800" y="5760720"/>
+            <a:off x="6400800" y="5715000"/>
             <a:ext cx="5394960" cy="457200"/>
           </a:xfrm>
           <a:prstGeom prst="rect">
@@ -4521,7 +4615,49 @@
                 </a:solidFill>
                 <a:latin typeface="Calibri"/>
               </a:rPr>
-              <a:t>Demand scenarios derived from real trial data.</a:t>
+              <a:t>Demand scenarios built from real DfT shared-micromobility data.</a:t>
+            </a:r>
+          </a:p>
+        </p:txBody>
+      </p:sp>
+      <p:sp>
+        <p:nvSpPr>
+          <p:cNvPr id="6" name="TextBox 5"/>
+          <p:cNvSpPr txBox="1"/>
+          <p:nvPr/>
+        </p:nvSpPr>
+        <p:spPr>
+          <a:xfrm>
+            <a:off x="640080" y="6419088"/>
+            <a:ext cx="10972800" cy="365760"/>
+          </a:xfrm>
+          <a:prstGeom prst="rect">
+            <a:avLst/>
+          </a:prstGeom>
+          <a:noFill/>
+        </p:spPr>
+        <p:txBody>
+          <a:bodyPr wrap="square" anchor="t" lIns="0" rIns="0" tIns="0" bIns="0">
+            <a:spAutoFit/>
+          </a:bodyPr>
+          <a:lstStyle/>
+          <a:p>
+            <a:pPr algn="l">
+              <a:lnSpc>
+                <a:spcPct val="105000"/>
+              </a:lnSpc>
+              <a:spcAft>
+                <a:spcPts val="600"/>
+              </a:spcAft>
+            </a:pPr>
+            <a:r>
+              <a:rPr sz="1050" b="0" i="1">
+                <a:solidFill>
+                  <a:srgbClr val="5A5A66"/>
+                </a:solidFill>
+                <a:latin typeface="Calibri"/>
+              </a:rPr>
+              <a:t>Judging criterion: Case Understanding (10%)</a:t>
             </a:r>
           </a:p>
         </p:txBody>
@@ -4583,13 +4719,13 @@
               </a:spcAft>
             </a:pPr>
             <a:r>
-              <a:rPr sz="3200" b="1" i="0">
+              <a:rPr sz="2800" b="1" i="0">
                 <a:solidFill>
                   <a:srgbClr val="1B1B3A"/>
                 </a:solidFill>
                 <a:latin typeface="Georgia"/>
               </a:rPr>
-              <a:t>Approach — a reproducible robust-design pipeline</a:t>
+              <a:t>Approach: 15 futures x 8,760 hours x 150 designs x 5 decision rules</a:t>
             </a:r>
           </a:p>
         </p:txBody>
@@ -4610,14 +4746,56 @@
         </p:blipFill>
         <p:spPr>
           <a:xfrm>
-            <a:off x="2771854" y="1143000"/>
-            <a:ext cx="6617811" cy="4937760"/>
+            <a:off x="2833130" y="1143000"/>
+            <a:ext cx="6495259" cy="4846320"/>
           </a:xfrm>
           <a:prstGeom prst="rect">
             <a:avLst/>
           </a:prstGeom>
         </p:spPr>
       </p:pic>
+      <p:sp>
+        <p:nvSpPr>
+          <p:cNvPr id="4" name="TextBox 3"/>
+          <p:cNvSpPr txBox="1"/>
+          <p:nvPr/>
+        </p:nvSpPr>
+        <p:spPr>
+          <a:xfrm>
+            <a:off x="640080" y="6419088"/>
+            <a:ext cx="10972800" cy="365760"/>
+          </a:xfrm>
+          <a:prstGeom prst="rect">
+            <a:avLst/>
+          </a:prstGeom>
+          <a:noFill/>
+        </p:spPr>
+        <p:txBody>
+          <a:bodyPr wrap="square" anchor="t" lIns="0" rIns="0" tIns="0" bIns="0">
+            <a:spAutoFit/>
+          </a:bodyPr>
+          <a:lstStyle/>
+          <a:p>
+            <a:pPr algn="l">
+              <a:lnSpc>
+                <a:spcPct val="105000"/>
+              </a:lnSpc>
+              <a:spcAft>
+                <a:spcPts val="600"/>
+              </a:spcAft>
+            </a:pPr>
+            <a:r>
+              <a:rPr sz="1050" b="0" i="1">
+                <a:solidFill>
+                  <a:srgbClr val="5A5A66"/>
+                </a:solidFill>
+                <a:latin typeface="Calibri"/>
+              </a:rPr>
+              <a:t>Judging criterion: Approach / Methodology (10%)</a:t>
+            </a:r>
+          </a:p>
+        </p:txBody>
+      </p:sp>
     </p:spTree>
   </p:cSld>
   <p:clrMapOvr>
@@ -4675,13 +4853,13 @@
               </a:spcAft>
             </a:pPr>
             <a:r>
-              <a:rPr sz="3200" b="1" i="0">
+              <a:rPr sz="3000" b="1" i="0">
                 <a:solidFill>
                   <a:srgbClr val="1B1B3A"/>
                 </a:solidFill>
                 <a:latin typeface="Georgia"/>
               </a:rPr>
-              <a:t>The result: robustness pays</a:t>
+              <a:t>The result: robustness pays - and it is buildable today</a:t>
             </a:r>
           </a:p>
         </p:txBody>
@@ -4702,7 +4880,7 @@
         </p:blipFill>
         <p:spPr>
           <a:xfrm>
-            <a:off x="548640" y="2026642"/>
+            <a:off x="548640" y="1980922"/>
             <a:ext cx="6766560" cy="3444794"/>
           </a:xfrm>
           <a:prstGeom prst="rect">
@@ -4718,7 +4896,7 @@
         </p:nvSpPr>
         <p:spPr>
           <a:xfrm>
-            <a:off x="7589520" y="1554480"/>
+            <a:off x="7589520" y="1463040"/>
             <a:ext cx="4206240" cy="822960"/>
           </a:xfrm>
           <a:prstGeom prst="rect">
@@ -4760,8 +4938,8 @@
         </p:nvSpPr>
         <p:spPr>
           <a:xfrm>
-            <a:off x="7589520" y="2267712"/>
-            <a:ext cx="4206240" cy="548640"/>
+            <a:off x="7589520" y="2258170"/>
+            <a:ext cx="4206240" cy="640080"/>
           </a:xfrm>
           <a:prstGeom prst="rect">
             <a:avLst/>
@@ -4802,7 +4980,7 @@
         </p:nvSpPr>
         <p:spPr>
           <a:xfrm>
-            <a:off x="7589520" y="2880360"/>
+            <a:off x="7589520" y="2743200"/>
             <a:ext cx="4206240" cy="822960"/>
           </a:xfrm>
           <a:prstGeom prst="rect">
@@ -4831,7 +5009,7 @@
                 </a:solidFill>
                 <a:latin typeface="Georgia"/>
               </a:rPr>
-              <a:t>95% -&gt; 100%</a:t>
+              <a:t>95.3% -&gt; 99.6%</a:t>
             </a:r>
           </a:p>
         </p:txBody>
@@ -4844,8 +5022,8 @@
         </p:nvSpPr>
         <p:spPr>
           <a:xfrm>
-            <a:off x="7589520" y="3593591"/>
-            <a:ext cx="4206240" cy="548640"/>
+            <a:off x="7589520" y="3538330"/>
+            <a:ext cx="4206240" cy="640080"/>
           </a:xfrm>
           <a:prstGeom prst="rect">
             <a:avLst/>
@@ -4873,7 +5051,7 @@
                 </a:solidFill>
                 <a:latin typeface="Calibri"/>
               </a:rPr>
-              <a:t>guaranteed fleet service, worst demand</a:t>
+              <a:t>guaranteed fleet service in the worst future</a:t>
             </a:r>
           </a:p>
         </p:txBody>
@@ -4886,7 +5064,7 @@
         </p:nvSpPr>
         <p:spPr>
           <a:xfrm>
-            <a:off x="7589520" y="4206240"/>
+            <a:off x="7589520" y="4023360"/>
             <a:ext cx="4206240" cy="822960"/>
           </a:xfrm>
           <a:prstGeom prst="rect">
@@ -4909,13 +5087,13 @@
               </a:spcAft>
             </a:pPr>
             <a:r>
-              <a:rPr sz="4000" b="1" i="0">
+              <a:rPr sz="3000" b="1" i="0">
                 <a:solidFill>
                   <a:srgbClr val="1B1B3A"/>
                 </a:solidFill>
                 <a:latin typeface="Georgia"/>
               </a:rPr>
-              <a:t>£19,232/yr</a:t>
+              <a:t>15 kWp + 8 bays</a:t>
             </a:r>
           </a:p>
         </p:txBody>
@@ -4928,8 +5106,8 @@
         </p:nvSpPr>
         <p:spPr>
           <a:xfrm>
-            <a:off x="7589520" y="4919472"/>
-            <a:ext cx="4206240" cy="548640"/>
+            <a:off x="7589520" y="4619707"/>
+            <a:ext cx="4206240" cy="640080"/>
           </a:xfrm>
           <a:prstGeom prst="rect">
             <a:avLst/>
@@ -4957,7 +5135,7 @@
                 </a:solidFill>
                 <a:latin typeface="Calibri"/>
               </a:rPr>
-              <a:t>robust worst-case cost (down from £47,179)</a:t>
+              <a:t>recommended hub - GBP 29,400 CAPEX, no battery at 15 kW</a:t>
             </a:r>
           </a:p>
         </p:txBody>
@@ -4970,8 +5148,50 @@
         </p:nvSpPr>
         <p:spPr>
           <a:xfrm>
-            <a:off x="7589520" y="5486400"/>
-            <a:ext cx="4206240" cy="822960"/>
+            <a:off x="7589520" y="5120640"/>
+            <a:ext cx="4206240" cy="1097280"/>
+          </a:xfrm>
+          <a:prstGeom prst="rect">
+            <a:avLst/>
+          </a:prstGeom>
+          <a:noFill/>
+        </p:spPr>
+        <p:txBody>
+          <a:bodyPr wrap="square" anchor="t" lIns="0" rIns="0" tIns="0" bIns="0">
+            <a:spAutoFit/>
+          </a:bodyPr>
+          <a:lstStyle/>
+          <a:p>
+            <a:pPr algn="l">
+              <a:lnSpc>
+                <a:spcPct val="115000"/>
+              </a:lnSpc>
+              <a:spcAft>
+                <a:spcPts val="600"/>
+              </a:spcAft>
+            </a:pPr>
+            <a:r>
+              <a:rPr sz="1200" b="0" i="0">
+                <a:solidFill>
+                  <a:srgbClr val="5A5A66"/>
+                </a:solidFill>
+                <a:latin typeface="Calibri"/>
+              </a:rPr>
+              <a:t>Off-the-shelf mono-Si PV, standard 3 kW AC bays; smart charging replaces storage at a connected site. 9/9 model outputs validated against published ranges.</a:t>
+            </a:r>
+          </a:p>
+        </p:txBody>
+      </p:sp>
+      <p:sp>
+        <p:nvSpPr>
+          <p:cNvPr id="11" name="TextBox 10"/>
+          <p:cNvSpPr txBox="1"/>
+          <p:nvPr/>
+        </p:nvSpPr>
+        <p:spPr>
+          <a:xfrm>
+            <a:off x="640080" y="6419088"/>
+            <a:ext cx="10972800" cy="365760"/>
           </a:xfrm>
           <a:prstGeom prst="rect">
             <a:avLst/>
@@ -4993,13 +5213,13 @@
               </a:spcAft>
             </a:pPr>
             <a:r>
-              <a:rPr sz="1200" b="0" i="1">
+              <a:rPr sz="1050" b="0" i="1">
                 <a:solidFill>
                   <a:srgbClr val="5A5A66"/>
                 </a:solidFill>
                 <a:latin typeface="Calibri"/>
               </a:rPr>
-              <a:t>A small expected-cost premium buys large protection against the demand tail.</a:t>
+              <a:t>Judging criteria: Technical Feasibility (10%) + headline result</a:t>
             </a:r>
           </a:p>
         </p:txBody>
@@ -5038,7 +5258,7 @@
         </p:nvSpPr>
         <p:spPr>
           <a:xfrm>
-            <a:off x="640080" y="457200"/>
+            <a:off x="640080" y="411480"/>
             <a:ext cx="10972800" cy="731520"/>
           </a:xfrm>
           <a:prstGeom prst="rect">
@@ -5067,7 +5287,7 @@
                 </a:solidFill>
                 <a:latin typeface="Georgia"/>
               </a:rPr>
-              <a:t>Theme 2 — route energy &amp; charge/discharge profiles</a:t>
+              <a:t>Scalable, safe, and costed end-to-end</a:t>
             </a:r>
           </a:p>
         </p:txBody>
@@ -5080,14 +5300,14 @@
         </p:nvSpPr>
         <p:spPr>
           <a:xfrm>
-            <a:off x="640080" y="1325880"/>
-            <a:ext cx="3291840" cy="384048"/>
+            <a:off x="640080" y="1234440"/>
+            <a:ext cx="3611880" cy="384048"/>
           </a:xfrm>
           <a:prstGeom prst="roundRect">
             <a:avLst/>
           </a:prstGeom>
           <a:solidFill>
-            <a:srgbClr val="F2B705"/>
+            <a:srgbClr val="2E86AB"/>
           </a:solidFill>
           <a:ln>
             <a:noFill/>
@@ -5119,27 +5339,162 @@
                 </a:solidFill>
                 <a:latin typeface="Calibri"/>
               </a:rPr>
-              <a:t>4-18 Wh/km by route</a:t>
-            </a:r>
-          </a:p>
-        </p:txBody>
-      </p:sp>
-      <p:sp>
-        <p:nvSpPr>
-          <p:cNvPr id="4" name="Rounded Rectangle 3"/>
+              <a:t>SCALABILITY</a:t>
+            </a:r>
+          </a:p>
+        </p:txBody>
+      </p:sp>
+      <p:sp>
+        <p:nvSpPr>
+          <p:cNvPr id="4" name="TextBox 3"/>
+          <p:cNvSpPr txBox="1"/>
+          <p:nvPr/>
+        </p:nvSpPr>
+        <p:spPr>
+          <a:xfrm>
+            <a:off x="640080" y="1783080"/>
+            <a:ext cx="3611880" cy="4206240"/>
+          </a:xfrm>
+          <a:prstGeom prst="rect">
+            <a:avLst/>
+          </a:prstGeom>
+          <a:noFill/>
+        </p:spPr>
+        <p:txBody>
+          <a:bodyPr wrap="square" anchor="t" lIns="0" rIns="0" tIns="0" bIns="0">
+            <a:spAutoFit/>
+          </a:bodyPr>
+          <a:lstStyle/>
+          <a:p>
+            <a:pPr algn="l">
+              <a:lnSpc>
+                <a:spcPct val="110000"/>
+              </a:lnSpc>
+              <a:spcAft>
+                <a:spcPts val="800"/>
+              </a:spcAft>
+            </a:pPr>
+            <a:r>
+              <a:rPr sz="1250" b="1" i="0">
+                <a:solidFill>
+                  <a:srgbClr val="1B1B3A"/>
+                </a:solidFill>
+                <a:latin typeface="Calibri"/>
+              </a:rPr>
+              <a:t>Modular replication:</a:t>
+            </a:r>
+            <a:r>
+              <a:rPr sz="1250" b="0" i="0">
+                <a:solidFill>
+                  <a:srgbClr val="22222A"/>
+                </a:solidFill>
+                <a:latin typeface="Calibri"/>
+              </a:rPr>
+              <a:t> a city scales by copying GBP 29k hubs, not by grid reinforcement.</a:t>
+            </a:r>
+          </a:p>
+          <a:p>
+            <a:pPr algn="l">
+              <a:lnSpc>
+                <a:spcPct val="110000"/>
+              </a:lnSpc>
+              <a:spcAft>
+                <a:spcPts val="800"/>
+              </a:spcAft>
+            </a:pPr>
+            <a:r>
+              <a:rPr sz="1250" b="1" i="0">
+                <a:solidFill>
+                  <a:srgbClr val="1B1B3A"/>
+                </a:solidFill>
+                <a:latin typeface="Calibri"/>
+              </a:rPr>
+              <a:t>Site-agnostic pipeline:</a:t>
+            </a:r>
+            <a:r>
+              <a:rPr sz="1250" b="0" i="0">
+                <a:solidFill>
+                  <a:srgbClr val="22222A"/>
+                </a:solidFill>
+                <a:latin typeface="Calibri"/>
+              </a:rPr>
+              <a:t> swap coordinates, demand file and grid cap - the model re-sizes any site.</a:t>
+            </a:r>
+          </a:p>
+          <a:p>
+            <a:pPr algn="l">
+              <a:lnSpc>
+                <a:spcPct val="110000"/>
+              </a:lnSpc>
+              <a:spcAft>
+                <a:spcPts val="800"/>
+              </a:spcAft>
+            </a:pPr>
+            <a:r>
+              <a:rPr sz="1250" b="1" i="0">
+                <a:solidFill>
+                  <a:srgbClr val="1B1B3A"/>
+                </a:solidFill>
+                <a:latin typeface="Calibri"/>
+              </a:rPr>
+              <a:t>UK &lt;-&gt; India transfer:</a:t>
+            </a:r>
+            <a:r>
+              <a:rPr sz="1250" b="0" i="0">
+                <a:solidFill>
+                  <a:srgbClr val="22222A"/>
+                </a:solidFill>
+                <a:latin typeface="Calibri"/>
+              </a:rPr>
+              <a:t> re-run with Indian solar (~1.6x yield) and 2/3-wheeler fleets; the weak-grid battery case becomes the binding one.</a:t>
+            </a:r>
+          </a:p>
+          <a:p>
+            <a:pPr algn="l">
+              <a:lnSpc>
+                <a:spcPct val="110000"/>
+              </a:lnSpc>
+              <a:spcAft>
+                <a:spcPts val="800"/>
+              </a:spcAft>
+            </a:pPr>
+            <a:r>
+              <a:rPr sz="1250" b="1" i="0">
+                <a:solidFill>
+                  <a:srgbClr val="1B1B3A"/>
+                </a:solidFill>
+                <a:latin typeface="Calibri"/>
+              </a:rPr>
+              <a:t>Growth priced in:</a:t>
+            </a:r>
+            <a:r>
+              <a:rPr sz="1250" b="0" i="0">
+                <a:solidFill>
+                  <a:srgbClr val="22222A"/>
+                </a:solidFill>
+                <a:latin typeface="Calibri"/>
+              </a:rPr>
+              <a:t> sized across 0-15%/yr growth with saturation.</a:t>
+            </a:r>
+          </a:p>
+        </p:txBody>
+      </p:sp>
+      <p:sp>
+        <p:nvSpPr>
+          <p:cNvPr id="5" name="Rounded Rectangle 4"/>
           <p:cNvSpPr/>
           <p:nvPr/>
         </p:nvSpPr>
         <p:spPr>
           <a:xfrm>
-            <a:off x="4206240" y="1325880"/>
-            <a:ext cx="3749039" cy="384048"/>
+            <a:off x="4434840" y="1234440"/>
+            <a:ext cx="3611880" cy="384048"/>
           </a:xfrm>
           <a:prstGeom prst="roundRect">
             <a:avLst/>
           </a:prstGeom>
           <a:solidFill>
-            <a:srgbClr val="43AA8B"/>
+            <a:srgbClr val="D9534F"/>
           </a:solidFill>
           <a:ln>
             <a:noFill/>
@@ -5171,27 +5526,162 @@
                 </a:solidFill>
                 <a:latin typeface="Calibri"/>
               </a:rPr>
-              <a:t>shared bikes cycle 1.3x more</a:t>
-            </a:r>
-          </a:p>
-        </p:txBody>
-      </p:sp>
-      <p:sp>
-        <p:nvSpPr>
-          <p:cNvPr id="5" name="Rounded Rectangle 4"/>
+              <a:t>SAFETY</a:t>
+            </a:r>
+          </a:p>
+        </p:txBody>
+      </p:sp>
+      <p:sp>
+        <p:nvSpPr>
+          <p:cNvPr id="6" name="TextBox 5"/>
+          <p:cNvSpPr txBox="1"/>
+          <p:nvPr/>
+        </p:nvSpPr>
+        <p:spPr>
+          <a:xfrm>
+            <a:off x="4434840" y="1783080"/>
+            <a:ext cx="3611880" cy="4206240"/>
+          </a:xfrm>
+          <a:prstGeom prst="rect">
+            <a:avLst/>
+          </a:prstGeom>
+          <a:noFill/>
+        </p:spPr>
+        <p:txBody>
+          <a:bodyPr wrap="square" anchor="t" lIns="0" rIns="0" tIns="0" bIns="0">
+            <a:spAutoFit/>
+          </a:bodyPr>
+          <a:lstStyle/>
+          <a:p>
+            <a:pPr algn="l">
+              <a:lnSpc>
+                <a:spcPct val="110000"/>
+              </a:lnSpc>
+              <a:spcAft>
+                <a:spcPts val="800"/>
+              </a:spcAft>
+            </a:pPr>
+            <a:r>
+              <a:rPr sz="1250" b="1" i="0">
+                <a:solidFill>
+                  <a:srgbClr val="1B1B3A"/>
+                </a:solidFill>
+                <a:latin typeface="Calibri"/>
+              </a:rPr>
+              <a:t>LFP chemistry</a:t>
+            </a:r>
+            <a:r>
+              <a:rPr sz="1250" b="0" i="0">
+                <a:solidFill>
+                  <a:srgbClr val="22222A"/>
+                </a:solidFill>
+                <a:latin typeface="Calibri"/>
+              </a:rPr>
+              <a:t> where storage is used - cobalt-free, higher thermal-runaway onset than NMC.</a:t>
+            </a:r>
+          </a:p>
+          <a:p>
+            <a:pPr algn="l">
+              <a:lnSpc>
+                <a:spcPct val="110000"/>
+              </a:lnSpc>
+              <a:spcAft>
+                <a:spcPts val="800"/>
+              </a:spcAft>
+            </a:pPr>
+            <a:r>
+              <a:rPr sz="1250" b="1" i="0">
+                <a:solidFill>
+                  <a:srgbClr val="1B1B3A"/>
+                </a:solidFill>
+                <a:latin typeface="Calibri"/>
+              </a:rPr>
+              <a:t>Standards-mapped:</a:t>
+            </a:r>
+            <a:r>
+              <a:rPr sz="1250" b="0" i="0">
+                <a:solidFill>
+                  <a:srgbClr val="22222A"/>
+                </a:solidFill>
+                <a:latin typeface="Calibri"/>
+              </a:rPr>
+              <a:t> BS EN 62485-5, BS EN 50604-1, BS 7671; IP65 outdoor bays; Type-B RCD per circuit.</a:t>
+            </a:r>
+          </a:p>
+          <a:p>
+            <a:pPr algn="l">
+              <a:lnSpc>
+                <a:spcPct val="110000"/>
+              </a:lnSpc>
+              <a:spcAft>
+                <a:spcPts val="800"/>
+              </a:spcAft>
+            </a:pPr>
+            <a:r>
+              <a:rPr sz="1250" b="1" i="0">
+                <a:solidFill>
+                  <a:srgbClr val="1B1B3A"/>
+                </a:solidFill>
+                <a:latin typeface="Calibri"/>
+              </a:rPr>
+              <a:t>Layout &amp; fire:</a:t>
+            </a:r>
+            <a:r>
+              <a:rPr sz="1250" b="0" i="0">
+                <a:solidFill>
+                  <a:srgbClr val="22222A"/>
+                </a:solidFill>
+                <a:latin typeface="Calibri"/>
+              </a:rPr>
+              <a:t> outdoor battery cabinet, 1 m clearance, thermal cut-off; sheltered, ventilated bays away from escape routes.</a:t>
+            </a:r>
+          </a:p>
+          <a:p>
+            <a:pPr algn="l">
+              <a:lnSpc>
+                <a:spcPct val="110000"/>
+              </a:lnSpc>
+              <a:spcAft>
+                <a:spcPts val="800"/>
+              </a:spcAft>
+            </a:pPr>
+            <a:r>
+              <a:rPr sz="1250" b="1" i="0">
+                <a:solidFill>
+                  <a:srgbClr val="1B1B3A"/>
+                </a:solidFill>
+                <a:latin typeface="Calibri"/>
+              </a:rPr>
+              <a:t>Peak enforced twice:</a:t>
+            </a:r>
+            <a:r>
+              <a:rPr sz="1250" b="0" i="0">
+                <a:solidFill>
+                  <a:srgbClr val="22222A"/>
+                </a:solidFill>
+                <a:latin typeface="Calibri"/>
+              </a:rPr>
+              <a:t> in software (EMS schedule) and hardware (supply fusing).</a:t>
+            </a:r>
+          </a:p>
+        </p:txBody>
+      </p:sp>
+      <p:sp>
+        <p:nvSpPr>
+          <p:cNvPr id="7" name="Rounded Rectangle 6"/>
           <p:cNvSpPr/>
           <p:nvPr/>
         </p:nvSpPr>
         <p:spPr>
           <a:xfrm>
-            <a:off x="8229600" y="1325880"/>
-            <a:ext cx="3291840" cy="384048"/>
+            <a:off x="8229600" y="1234440"/>
+            <a:ext cx="3611880" cy="384048"/>
           </a:xfrm>
           <a:prstGeom prst="roundRect">
             <a:avLst/>
           </a:prstGeom>
           <a:solidFill>
-            <a:srgbClr val="2E86AB"/>
+            <a:srgbClr val="43AA8B"/>
           </a:solidFill>
           <a:ln>
             <a:noFill/>
@@ -5223,45 +5713,21 @@
                 </a:solidFill>
                 <a:latin typeface="Calibri"/>
               </a:rPr>
-              <a:t>battery only if grid &lt;= 9 kW</a:t>
-            </a:r>
-          </a:p>
-        </p:txBody>
-      </p:sp>
-      <p:pic>
-        <p:nvPicPr>
-          <p:cNvPr id="6" name="Picture 5" descr="13_route_profiles.png"/>
-          <p:cNvPicPr>
-            <a:picLocks noChangeAspect="1"/>
-          </p:cNvPicPr>
-          <p:nvPr/>
-        </p:nvPicPr>
-        <p:blipFill>
-          <a:blip r:embed="rId2"/>
-          <a:stretch>
-            <a:fillRect/>
-          </a:stretch>
-        </p:blipFill>
-        <p:spPr>
-          <a:xfrm>
-            <a:off x="731520" y="2173938"/>
-            <a:ext cx="10698480" cy="3515963"/>
-          </a:xfrm>
-          <a:prstGeom prst="rect">
-            <a:avLst/>
-          </a:prstGeom>
-        </p:spPr>
-      </p:pic>
-      <p:sp>
-        <p:nvSpPr>
-          <p:cNvPr id="7" name="TextBox 6"/>
+              <a:t>COST ANALYSIS</a:t>
+            </a:r>
+          </a:p>
+        </p:txBody>
+      </p:sp>
+      <p:sp>
+        <p:nvSpPr>
+          <p:cNvPr id="8" name="TextBox 7"/>
           <p:cNvSpPr txBox="1"/>
           <p:nvPr/>
         </p:nvSpPr>
         <p:spPr>
           <a:xfrm>
-            <a:off x="731520" y="5943600"/>
-            <a:ext cx="10698480" cy="548640"/>
+            <a:off x="8229600" y="1783080"/>
+            <a:ext cx="3611880" cy="4206240"/>
           </a:xfrm>
           <a:prstGeom prst="rect">
             <a:avLst/>
@@ -5274,7 +5740,142 @@
           </a:bodyPr>
           <a:lstStyle/>
           <a:p>
-            <a:pPr algn="ctr">
+            <a:pPr algn="l">
+              <a:lnSpc>
+                <a:spcPct val="110000"/>
+              </a:lnSpc>
+              <a:spcAft>
+                <a:spcPts val="800"/>
+              </a:spcAft>
+            </a:pPr>
+            <a:r>
+              <a:rPr sz="1250" b="1" i="0">
+                <a:solidFill>
+                  <a:srgbClr val="1B1B3A"/>
+                </a:solidFill>
+                <a:latin typeface="Calibri"/>
+              </a:rPr>
+              <a:t>GBP 29,400 CAPEX</a:t>
+            </a:r>
+            <a:r>
+              <a:rPr sz="1250" b="0" i="0">
+                <a:solidFill>
+                  <a:srgbClr val="22222A"/>
+                </a:solidFill>
+                <a:latin typeface="Calibri"/>
+              </a:rPr>
+              <a:t> - PV, bays, installation; battery-free at 15 kW.</a:t>
+            </a:r>
+          </a:p>
+          <a:p>
+            <a:pPr algn="l">
+              <a:lnSpc>
+                <a:spcPct val="110000"/>
+              </a:lnSpc>
+              <a:spcAft>
+                <a:spcPts val="800"/>
+              </a:spcAft>
+            </a:pPr>
+            <a:r>
+              <a:rPr sz="1250" b="1" i="0">
+                <a:solidFill>
+                  <a:srgbClr val="1B1B3A"/>
+                </a:solidFill>
+                <a:latin typeface="Calibri"/>
+              </a:rPr>
+              <a:t>GBP 19,232/yr worst-case</a:t>
+            </a:r>
+            <a:r>
+              <a:rPr sz="1250" b="0" i="0">
+                <a:solidFill>
+                  <a:srgbClr val="22222A"/>
+                </a:solidFill>
+                <a:latin typeface="Calibri"/>
+              </a:rPr>
+              <a:t> vs GBP 47,179 naive - the premium repays in the first bad year.</a:t>
+            </a:r>
+          </a:p>
+          <a:p>
+            <a:pPr algn="l">
+              <a:lnSpc>
+                <a:spcPct val="110000"/>
+              </a:lnSpc>
+              <a:spcAft>
+                <a:spcPts val="800"/>
+              </a:spcAft>
+            </a:pPr>
+            <a:r>
+              <a:rPr sz="1250" b="1" i="0">
+                <a:solidFill>
+                  <a:srgbClr val="1B1B3A"/>
+                </a:solidFill>
+                <a:latin typeface="Calibri"/>
+              </a:rPr>
+              <a:t>LCOE GBP 0.253/kWh</a:t>
+            </a:r>
+            <a:r>
+              <a:rPr sz="1250" b="0" i="0">
+                <a:solidFill>
+                  <a:srgbClr val="22222A"/>
+                </a:solidFill>
+                <a:latin typeface="Calibri"/>
+              </a:rPr>
+              <a:t> delivered, incl. time-of-use tariff, GBP 80/kW-yr demand charge, PV residual value, DoD-aware battery ageing.</a:t>
+            </a:r>
+          </a:p>
+          <a:p>
+            <a:pPr algn="l">
+              <a:lnSpc>
+                <a:spcPct val="110000"/>
+              </a:lnSpc>
+              <a:spcAft>
+                <a:spcPts val="800"/>
+              </a:spcAft>
+            </a:pPr>
+            <a:r>
+              <a:rPr sz="1250" b="1" i="0">
+                <a:solidFill>
+                  <a:srgbClr val="1B1B3A"/>
+                </a:solidFill>
+                <a:latin typeface="Calibri"/>
+              </a:rPr>
+              <a:t>3.7 tCO2/yr avoided</a:t>
+            </a:r>
+            <a:r>
+              <a:rPr sz="1250" b="0" i="0">
+                <a:solidFill>
+                  <a:srgbClr val="22222A"/>
+                </a:solidFill>
+                <a:latin typeface="Calibri"/>
+              </a:rPr>
+              <a:t> (15% vs grid-only, marginal basis) - 55 t over the PV lifetime.</a:t>
+            </a:r>
+          </a:p>
+        </p:txBody>
+      </p:sp>
+      <p:sp>
+        <p:nvSpPr>
+          <p:cNvPr id="9" name="TextBox 8"/>
+          <p:cNvSpPr txBox="1"/>
+          <p:nvPr/>
+        </p:nvSpPr>
+        <p:spPr>
+          <a:xfrm>
+            <a:off x="640080" y="6419088"/>
+            <a:ext cx="10972800" cy="365760"/>
+          </a:xfrm>
+          <a:prstGeom prst="rect">
+            <a:avLst/>
+          </a:prstGeom>
+          <a:noFill/>
+        </p:spPr>
+        <p:txBody>
+          <a:bodyPr wrap="square" anchor="t" lIns="0" rIns="0" tIns="0" bIns="0">
+            <a:spAutoFit/>
+          </a:bodyPr>
+          <a:lstStyle/>
+          <a:p>
+            <a:pPr algn="l">
               <a:lnSpc>
                 <a:spcPct val="105000"/>
               </a:lnSpc>
@@ -5283,13 +5884,13 @@
               </a:spcAft>
             </a:pPr>
             <a:r>
-              <a:rPr sz="1100" b="0" i="1">
+              <a:rPr sz="1050" b="0" i="1">
                 <a:solidFill>
                   <a:srgbClr val="5A5A66"/>
                 </a:solidFill>
                 <a:latin typeface="Calibri"/>
               </a:rPr>
-              <a:t>A physics model gives energy per km by route; private bikes take one deep overnight home charge, shared bikes discharge deeper over many trips and recharge at the depot — so shared fleets need the managed hub.</a:t>
+              <a:t>Judging criterion: Scalability, Safety &amp; Cost Analysis (10%)</a:t>
             </a:r>
           </a:p>
         </p:txBody>
@@ -5308,7 +5909,7 @@
     <p:bg>
       <p:bgPr>
         <a:solidFill>
-          <a:srgbClr val="FFFFFF"/>
+          <a:srgbClr val="1B1B3A"/>
         </a:solidFill>
         <a:effectLst/>
       </p:bgPr>
@@ -5328,8 +5929,8 @@
         </p:nvSpPr>
         <p:spPr>
           <a:xfrm>
-            <a:off x="640080" y="457200"/>
-            <a:ext cx="10972800" cy="731520"/>
+            <a:off x="822960" y="640080"/>
+            <a:ext cx="10515600" cy="822960"/>
           </a:xfrm>
           <a:prstGeom prst="rect">
             <a:avLst/>
@@ -5351,27 +5952,78 @@
               </a:spcAft>
             </a:pPr>
             <a:r>
-              <a:rPr sz="3200" b="1" i="0">
+              <a:rPr sz="3600" b="1" i="0">
+                <a:solidFill>
+                  <a:srgbClr val="F2B705"/>
+                </a:solidFill>
+                <a:latin typeface="Georgia"/>
+              </a:rPr>
+              <a:t>Now - the model itself, live</a:t>
+            </a:r>
+          </a:p>
+        </p:txBody>
+      </p:sp>
+      <p:sp>
+        <p:nvSpPr>
+          <p:cNvPr id="3" name="Oval 2"/>
+          <p:cNvSpPr/>
+          <p:nvPr/>
+        </p:nvSpPr>
+        <p:spPr>
+          <a:xfrm>
+            <a:off x="868680" y="1737360"/>
+            <a:ext cx="457200" cy="457200"/>
+          </a:xfrm>
+          <a:prstGeom prst="ellipse">
+            <a:avLst/>
+          </a:prstGeom>
+          <a:solidFill>
+            <a:srgbClr val="F2B705"/>
+          </a:solidFill>
+          <a:ln>
+            <a:noFill/>
+          </a:ln>
+        </p:spPr>
+        <p:style>
+          <a:lnRef idx="1">
+            <a:schemeClr val="accent1"/>
+          </a:lnRef>
+          <a:fillRef idx="3">
+            <a:schemeClr val="accent1"/>
+          </a:fillRef>
+          <a:effectRef idx="2">
+            <a:schemeClr val="accent1"/>
+          </a:effectRef>
+          <a:fontRef idx="minor">
+            <a:schemeClr val="lt1"/>
+          </a:fontRef>
+        </p:style>
+        <p:txBody>
+          <a:bodyPr rtlCol="0" anchor="ctr"/>
+          <a:lstStyle/>
+          <a:p>
+            <a:pPr algn="ctr"/>
+            <a:r>
+              <a:rPr b="1" sz="1800">
                 <a:solidFill>
                   <a:srgbClr val="1B1B3A"/>
                 </a:solidFill>
-                <a:latin typeface="Georgia"/>
-              </a:rPr>
-              <a:t>Feasible today — and sustainable</a:t>
-            </a:r>
-          </a:p>
-        </p:txBody>
-      </p:sp>
-      <p:sp>
-        <p:nvSpPr>
-          <p:cNvPr id="3" name="TextBox 2"/>
+              </a:rPr>
+              <a:t>1</a:t>
+            </a:r>
+          </a:p>
+        </p:txBody>
+      </p:sp>
+      <p:sp>
+        <p:nvSpPr>
+          <p:cNvPr id="4" name="TextBox 3"/>
           <p:cNvSpPr txBox="1"/>
           <p:nvPr/>
         </p:nvSpPr>
         <p:spPr>
           <a:xfrm>
-            <a:off x="731520" y="1554480"/>
-            <a:ext cx="5486400" cy="822960"/>
+            <a:off x="1554480" y="1700784"/>
+            <a:ext cx="6035040" cy="457200"/>
           </a:xfrm>
           <a:prstGeom prst="rect">
             <a:avLst/>
@@ -5393,27 +6045,27 @@
               </a:spcAft>
             </a:pPr>
             <a:r>
-              <a:rPr sz="4000" b="1" i="0">
-                <a:solidFill>
-                  <a:srgbClr val="1B1B3A"/>
-                </a:solidFill>
-                <a:latin typeface="Georgia"/>
-              </a:rPr>
-              <a:t>~£29,400</a:t>
-            </a:r>
-          </a:p>
-        </p:txBody>
-      </p:sp>
-      <p:sp>
-        <p:nvSpPr>
-          <p:cNvPr id="4" name="TextBox 3"/>
+              <a:rPr sz="1700" b="1" i="0">
+                <a:solidFill>
+                  <a:srgbClr val="FFFFFF"/>
+                </a:solidFill>
+                <a:latin typeface="Calibri"/>
+              </a:rPr>
+              <a:t>The hub, animated</a:t>
+            </a:r>
+          </a:p>
+        </p:txBody>
+      </p:sp>
+      <p:sp>
+        <p:nvSpPr>
+          <p:cNvPr id="5" name="TextBox 4"/>
           <p:cNvSpPr txBox="1"/>
           <p:nvPr/>
         </p:nvSpPr>
         <p:spPr>
           <a:xfrm>
-            <a:off x="731520" y="2267712"/>
-            <a:ext cx="5486400" cy="548640"/>
+            <a:off x="1554480" y="2084831"/>
+            <a:ext cx="6035040" cy="548640"/>
           </a:xfrm>
           <a:prstGeom prst="rect">
             <a:avLst/>
@@ -5437,25 +6089,76 @@
             <a:r>
               <a:rPr sz="1250" b="0" i="0">
                 <a:solidFill>
-                  <a:srgbClr val="5A5A66"/>
+                  <a:srgbClr val="CADCFC"/>
                 </a:solidFill>
                 <a:latin typeface="Calibri"/>
               </a:rPr>
-              <a:t>capital cost — off-the-shelf PV, Li-ion &amp; AC chargers</a:t>
-            </a:r>
-          </a:p>
-        </p:txBody>
-      </p:sp>
-      <p:sp>
-        <p:nvSpPr>
-          <p:cNvPr id="5" name="TextBox 4"/>
+              <a:t>hour-by-hour dispatch of the real model - sun up, bikes out, smart charging into the sun</a:t>
+            </a:r>
+          </a:p>
+        </p:txBody>
+      </p:sp>
+      <p:sp>
+        <p:nvSpPr>
+          <p:cNvPr id="6" name="Oval 5"/>
+          <p:cNvSpPr/>
+          <p:nvPr/>
+        </p:nvSpPr>
+        <p:spPr>
+          <a:xfrm>
+            <a:off x="868680" y="2761488"/>
+            <a:ext cx="457200" cy="457200"/>
+          </a:xfrm>
+          <a:prstGeom prst="ellipse">
+            <a:avLst/>
+          </a:prstGeom>
+          <a:solidFill>
+            <a:srgbClr val="F2B705"/>
+          </a:solidFill>
+          <a:ln>
+            <a:noFill/>
+          </a:ln>
+        </p:spPr>
+        <p:style>
+          <a:lnRef idx="1">
+            <a:schemeClr val="accent1"/>
+          </a:lnRef>
+          <a:fillRef idx="3">
+            <a:schemeClr val="accent1"/>
+          </a:fillRef>
+          <a:effectRef idx="2">
+            <a:schemeClr val="accent1"/>
+          </a:effectRef>
+          <a:fontRef idx="minor">
+            <a:schemeClr val="lt1"/>
+          </a:fontRef>
+        </p:style>
+        <p:txBody>
+          <a:bodyPr rtlCol="0" anchor="ctr"/>
+          <a:lstStyle/>
+          <a:p>
+            <a:pPr algn="ctr"/>
+            <a:r>
+              <a:rPr b="1" sz="1800">
+                <a:solidFill>
+                  <a:srgbClr val="1B1B3A"/>
+                </a:solidFill>
+              </a:rPr>
+              <a:t>2</a:t>
+            </a:r>
+          </a:p>
+        </p:txBody>
+      </p:sp>
+      <p:sp>
+        <p:nvSpPr>
+          <p:cNvPr id="7" name="TextBox 6"/>
           <p:cNvSpPr txBox="1"/>
           <p:nvPr/>
         </p:nvSpPr>
         <p:spPr>
           <a:xfrm>
-            <a:off x="731520" y="2880360"/>
-            <a:ext cx="5486400" cy="822960"/>
+            <a:off x="1554480" y="2724912"/>
+            <a:ext cx="6035040" cy="457200"/>
           </a:xfrm>
           <a:prstGeom prst="rect">
             <a:avLst/>
@@ -5477,27 +6180,27 @@
               </a:spcAft>
             </a:pPr>
             <a:r>
-              <a:rPr sz="4000" b="1" i="0">
-                <a:solidFill>
-                  <a:srgbClr val="43AA8B"/>
-                </a:solidFill>
-                <a:latin typeface="Georgia"/>
-              </a:rPr>
-              <a:t>-15% CO2</a:t>
-            </a:r>
-          </a:p>
-        </p:txBody>
-      </p:sp>
-      <p:sp>
-        <p:nvSpPr>
-          <p:cNvPr id="6" name="TextBox 5"/>
+              <a:rPr sz="1700" b="1" i="0">
+                <a:solidFill>
+                  <a:srgbClr val="FFFFFF"/>
+                </a:solidFill>
+                <a:latin typeface="Calibri"/>
+              </a:rPr>
+              <a:t>Break it, then fix it</a:t>
+            </a:r>
+          </a:p>
+        </p:txBody>
+      </p:sp>
+      <p:sp>
+        <p:nvSpPr>
+          <p:cNvPr id="8" name="TextBox 7"/>
           <p:cNvSpPr txBox="1"/>
           <p:nvPr/>
         </p:nvSpPr>
         <p:spPr>
           <a:xfrm>
-            <a:off x="731520" y="3593591"/>
-            <a:ext cx="5486400" cy="548640"/>
+            <a:off x="1554480" y="3108960"/>
+            <a:ext cx="6035040" cy="548640"/>
           </a:xfrm>
           <a:prstGeom prst="rect">
             <a:avLst/>
@@ -5521,25 +6224,76 @@
             <a:r>
               <a:rPr sz="1250" b="0" i="0">
                 <a:solidFill>
-                  <a:srgbClr val="5A5A66"/>
+                  <a:srgbClr val="CADCFC"/>
                 </a:solidFill>
                 <a:latin typeface="Calibri"/>
               </a:rPr>
-              <a:t>vs grid-only charging (3.7 tCO2/yr saved)</a:t>
-            </a:r>
-          </a:p>
-        </p:txBody>
-      </p:sp>
-      <p:sp>
-        <p:nvSpPr>
-          <p:cNvPr id="7" name="TextBox 6"/>
+              <a:t>the naive design collapses in the worst future; the robust design holds at 99.6%</a:t>
+            </a:r>
+          </a:p>
+        </p:txBody>
+      </p:sp>
+      <p:sp>
+        <p:nvSpPr>
+          <p:cNvPr id="9" name="Oval 8"/>
+          <p:cNvSpPr/>
+          <p:nvPr/>
+        </p:nvSpPr>
+        <p:spPr>
+          <a:xfrm>
+            <a:off x="868680" y="3785616"/>
+            <a:ext cx="457200" cy="457200"/>
+          </a:xfrm>
+          <a:prstGeom prst="ellipse">
+            <a:avLst/>
+          </a:prstGeom>
+          <a:solidFill>
+            <a:srgbClr val="F2B705"/>
+          </a:solidFill>
+          <a:ln>
+            <a:noFill/>
+          </a:ln>
+        </p:spPr>
+        <p:style>
+          <a:lnRef idx="1">
+            <a:schemeClr val="accent1"/>
+          </a:lnRef>
+          <a:fillRef idx="3">
+            <a:schemeClr val="accent1"/>
+          </a:fillRef>
+          <a:effectRef idx="2">
+            <a:schemeClr val="accent1"/>
+          </a:effectRef>
+          <a:fontRef idx="minor">
+            <a:schemeClr val="lt1"/>
+          </a:fontRef>
+        </p:style>
+        <p:txBody>
+          <a:bodyPr rtlCol="0" anchor="ctr"/>
+          <a:lstStyle/>
+          <a:p>
+            <a:pPr algn="ctr"/>
+            <a:r>
+              <a:rPr b="1" sz="1800">
+                <a:solidFill>
+                  <a:srgbClr val="1B1B3A"/>
+                </a:solidFill>
+              </a:rPr>
+              <a:t>3</a:t>
+            </a:r>
+          </a:p>
+        </p:txBody>
+      </p:sp>
+      <p:sp>
+        <p:nvSpPr>
+          <p:cNvPr id="10" name="TextBox 9"/>
           <p:cNvSpPr txBox="1"/>
           <p:nvPr/>
         </p:nvSpPr>
         <p:spPr>
           <a:xfrm>
-            <a:off x="731520" y="4206240"/>
-            <a:ext cx="5486400" cy="822960"/>
+            <a:off x="1554480" y="3749040"/>
+            <a:ext cx="6035040" cy="457200"/>
           </a:xfrm>
           <a:prstGeom prst="rect">
             <a:avLst/>
@@ -5561,27 +6315,27 @@
               </a:spcAft>
             </a:pPr>
             <a:r>
-              <a:rPr sz="4000" b="1" i="0">
-                <a:solidFill>
-                  <a:srgbClr val="2E86AB"/>
-                </a:solidFill>
-                <a:latin typeface="Georgia"/>
-              </a:rPr>
-              <a:t>9/9 validated</a:t>
-            </a:r>
-          </a:p>
-        </p:txBody>
-      </p:sp>
-      <p:sp>
-        <p:nvSpPr>
-          <p:cNvPr id="8" name="TextBox 7"/>
+              <a:rPr sz="1700" b="1" i="0">
+                <a:solidFill>
+                  <a:srgbClr val="FFFFFF"/>
+                </a:solidFill>
+                <a:latin typeface="Calibri"/>
+              </a:rPr>
+              <a:t>150 designs, searched live</a:t>
+            </a:r>
+          </a:p>
+        </p:txBody>
+      </p:sp>
+      <p:sp>
+        <p:nvSpPr>
+          <p:cNvPr id="11" name="TextBox 10"/>
           <p:cNvSpPr txBox="1"/>
           <p:nvPr/>
         </p:nvSpPr>
         <p:spPr>
           <a:xfrm>
-            <a:off x="731520" y="4919472"/>
-            <a:ext cx="5486400" cy="548640"/>
+            <a:off x="1554480" y="4133088"/>
+            <a:ext cx="6035040" cy="548640"/>
           </a:xfrm>
           <a:prstGeom prst="rect">
             <a:avLst/>
@@ -5605,18 +6359,153 @@
             <a:r>
               <a:rPr sz="1250" b="0" i="0">
                 <a:solidFill>
-                  <a:srgbClr val="5A5A66"/>
+                  <a:srgbClr val="CADCFC"/>
                 </a:solidFill>
                 <a:latin typeface="Calibri"/>
               </a:rPr>
-              <a:t>outputs &amp; demand inputs within published ranges; 1-command rebuild</a:t>
+              <a:t>the browser re-runs the full robust optimisation - 20 million simulated hours - in about a second</a:t>
+            </a:r>
+          </a:p>
+        </p:txBody>
+      </p:sp>
+      <p:sp>
+        <p:nvSpPr>
+          <p:cNvPr id="12" name="Oval 11"/>
+          <p:cNvSpPr/>
+          <p:nvPr/>
+        </p:nvSpPr>
+        <p:spPr>
+          <a:xfrm>
+            <a:off x="868680" y="4809744"/>
+            <a:ext cx="457200" cy="457200"/>
+          </a:xfrm>
+          <a:prstGeom prst="ellipse">
+            <a:avLst/>
+          </a:prstGeom>
+          <a:solidFill>
+            <a:srgbClr val="F2B705"/>
+          </a:solidFill>
+          <a:ln>
+            <a:noFill/>
+          </a:ln>
+        </p:spPr>
+        <p:style>
+          <a:lnRef idx="1">
+            <a:schemeClr val="accent1"/>
+          </a:lnRef>
+          <a:fillRef idx="3">
+            <a:schemeClr val="accent1"/>
+          </a:fillRef>
+          <a:effectRef idx="2">
+            <a:schemeClr val="accent1"/>
+          </a:effectRef>
+          <a:fontRef idx="minor">
+            <a:schemeClr val="lt1"/>
+          </a:fontRef>
+        </p:style>
+        <p:txBody>
+          <a:bodyPr rtlCol="0" anchor="ctr"/>
+          <a:lstStyle/>
+          <a:p>
+            <a:pPr algn="ctr"/>
+            <a:r>
+              <a:rPr b="1" sz="1800">
+                <a:solidFill>
+                  <a:srgbClr val="1B1B3A"/>
+                </a:solidFill>
+              </a:rPr>
+              <a:t>4</a:t>
+            </a:r>
+          </a:p>
+        </p:txBody>
+      </p:sp>
+      <p:sp>
+        <p:nvSpPr>
+          <p:cNvPr id="13" name="TextBox 12"/>
+          <p:cNvSpPr txBox="1"/>
+          <p:nvPr/>
+        </p:nvSpPr>
+        <p:spPr>
+          <a:xfrm>
+            <a:off x="1554480" y="4773168"/>
+            <a:ext cx="6035040" cy="457200"/>
+          </a:xfrm>
+          <a:prstGeom prst="rect">
+            <a:avLst/>
+          </a:prstGeom>
+          <a:noFill/>
+        </p:spPr>
+        <p:txBody>
+          <a:bodyPr wrap="square" anchor="t" lIns="0" rIns="0" tIns="0" bIns="0">
+            <a:spAutoFit/>
+          </a:bodyPr>
+          <a:lstStyle/>
+          <a:p>
+            <a:pPr algn="l">
+              <a:lnSpc>
+                <a:spcPct val="105000"/>
+              </a:lnSpc>
+              <a:spcAft>
+                <a:spcPts val="600"/>
+              </a:spcAft>
+            </a:pPr>
+            <a:r>
+              <a:rPr sz="1700" b="1" i="0">
+                <a:solidFill>
+                  <a:srgbClr val="FFFFFF"/>
+                </a:solidFill>
+                <a:latin typeface="Calibri"/>
+              </a:rPr>
+              <a:t>The storage boundary</a:t>
+            </a:r>
+          </a:p>
+        </p:txBody>
+      </p:sp>
+      <p:sp>
+        <p:nvSpPr>
+          <p:cNvPr id="14" name="TextBox 13"/>
+          <p:cNvSpPr txBox="1"/>
+          <p:nvPr/>
+        </p:nvSpPr>
+        <p:spPr>
+          <a:xfrm>
+            <a:off x="1554480" y="5157216"/>
+            <a:ext cx="6035040" cy="548640"/>
+          </a:xfrm>
+          <a:prstGeom prst="rect">
+            <a:avLst/>
+          </a:prstGeom>
+          <a:noFill/>
+        </p:spPr>
+        <p:txBody>
+          <a:bodyPr wrap="square" anchor="t" lIns="0" rIns="0" tIns="0" bIns="0">
+            <a:spAutoFit/>
+          </a:bodyPr>
+          <a:lstStyle/>
+          <a:p>
+            <a:pPr algn="l">
+              <a:lnSpc>
+                <a:spcPct val="105000"/>
+              </a:lnSpc>
+              <a:spcAft>
+                <a:spcPts val="600"/>
+              </a:spcAft>
+            </a:pPr>
+            <a:r>
+              <a:rPr sz="1250" b="0" i="0">
+                <a:solidFill>
+                  <a:srgbClr val="CADCFC"/>
+                </a:solidFill>
+                <a:latin typeface="Calibri"/>
+              </a:rPr>
+              <a:t>weaken the grid to 8 kW and watch a battery enter the optimal design</a:t>
             </a:r>
           </a:p>
         </p:txBody>
       </p:sp>
       <p:pic>
         <p:nvPicPr>
-          <p:cNvPr id="9" name="Picture 8" descr="08_energy_sources.png"/>
+          <p:cNvPr id="15" name="Picture 14" descr="_demo_qr.png"/>
           <p:cNvPicPr>
             <a:picLocks noChangeAspect="1"/>
           </p:cNvPicPr>
@@ -5630,14 +6519,182 @@
         </p:blipFill>
         <p:spPr>
           <a:xfrm>
-            <a:off x="6309360" y="2606040"/>
-            <a:ext cx="5486400" cy="2194560"/>
+            <a:off x="8503920" y="1828800"/>
+            <a:ext cx="2377440" cy="2377440"/>
           </a:xfrm>
           <a:prstGeom prst="rect">
             <a:avLst/>
           </a:prstGeom>
         </p:spPr>
       </p:pic>
+      <p:sp>
+        <p:nvSpPr>
+          <p:cNvPr id="16" name="TextBox 15"/>
+          <p:cNvSpPr txBox="1"/>
+          <p:nvPr/>
+        </p:nvSpPr>
+        <p:spPr>
+          <a:xfrm>
+            <a:off x="8046720" y="4343400"/>
+            <a:ext cx="3291840" cy="457200"/>
+          </a:xfrm>
+          <a:prstGeom prst="rect">
+            <a:avLst/>
+          </a:prstGeom>
+          <a:noFill/>
+        </p:spPr>
+        <p:txBody>
+          <a:bodyPr wrap="square" anchor="t" lIns="0" rIns="0" tIns="0" bIns="0">
+            <a:spAutoFit/>
+          </a:bodyPr>
+          <a:lstStyle/>
+          <a:p>
+            <a:pPr algn="ctr">
+              <a:lnSpc>
+                <a:spcPct val="105000"/>
+              </a:lnSpc>
+              <a:spcAft>
+                <a:spcPts val="600"/>
+              </a:spcAft>
+            </a:pPr>
+            <a:r>
+              <a:rPr sz="1150" b="0" i="0">
+                <a:solidFill>
+                  <a:srgbClr val="CADCFC"/>
+                </a:solidFill>
+                <a:latin typeface="Calibri"/>
+              </a:rPr>
+              <a:t>scan to open on your phone</a:t>
+            </a:r>
+          </a:p>
+        </p:txBody>
+      </p:sp>
+      <p:sp>
+        <p:nvSpPr>
+          <p:cNvPr id="17" name="TextBox 16"/>
+          <p:cNvSpPr txBox="1"/>
+          <p:nvPr/>
+        </p:nvSpPr>
+        <p:spPr>
+          <a:xfrm>
+            <a:off x="8046720" y="4846320"/>
+            <a:ext cx="3291840" cy="731520"/>
+          </a:xfrm>
+          <a:prstGeom prst="rect">
+            <a:avLst/>
+          </a:prstGeom>
+          <a:noFill/>
+        </p:spPr>
+        <p:txBody>
+          <a:bodyPr wrap="square" anchor="t" lIns="0" rIns="0" tIns="0" bIns="0">
+            <a:spAutoFit/>
+          </a:bodyPr>
+          <a:lstStyle/>
+          <a:p>
+            <a:pPr algn="ctr">
+              <a:lnSpc>
+                <a:spcPct val="105000"/>
+              </a:lnSpc>
+              <a:spcAft>
+                <a:spcPts val="600"/>
+              </a:spcAft>
+            </a:pPr>
+            <a:r>
+              <a:rPr sz="1300" b="1" i="0">
+                <a:solidFill>
+                  <a:srgbClr val="F2B705"/>
+                </a:solidFill>
+                <a:latin typeface="Calibri"/>
+              </a:rPr>
+              <a:t>gourav88502.github.io/emicromobility-robust-charging</a:t>
+            </a:r>
+          </a:p>
+        </p:txBody>
+      </p:sp>
+      <p:sp>
+        <p:nvSpPr>
+          <p:cNvPr id="18" name="TextBox 17"/>
+          <p:cNvSpPr txBox="1"/>
+          <p:nvPr/>
+        </p:nvSpPr>
+        <p:spPr>
+          <a:xfrm>
+            <a:off x="868680" y="5897880"/>
+            <a:ext cx="10424160" cy="457200"/>
+          </a:xfrm>
+          <a:prstGeom prst="rect">
+            <a:avLst/>
+          </a:prstGeom>
+          <a:noFill/>
+        </p:spPr>
+        <p:txBody>
+          <a:bodyPr wrap="square" anchor="t" lIns="0" rIns="0" tIns="0" bIns="0">
+            <a:spAutoFit/>
+          </a:bodyPr>
+          <a:lstStyle/>
+          <a:p>
+            <a:pPr algn="l">
+              <a:lnSpc>
+                <a:spcPct val="105000"/>
+              </a:lnSpc>
+              <a:spcAft>
+                <a:spcPts val="600"/>
+              </a:spcAft>
+            </a:pPr>
+            <a:r>
+              <a:rPr sz="1200" b="0" i="1">
+                <a:solidFill>
+                  <a:srgbClr val="CADCFC"/>
+                </a:solidFill>
+                <a:latin typeface="Calibri"/>
+              </a:rPr>
+              <a:t>Runs in any browser - no install, works offline; every number re-derived by the page and checked against the Python pipeline at load.</a:t>
+            </a:r>
+          </a:p>
+        </p:txBody>
+      </p:sp>
+      <p:sp>
+        <p:nvSpPr>
+          <p:cNvPr id="19" name="TextBox 18"/>
+          <p:cNvSpPr txBox="1"/>
+          <p:nvPr/>
+        </p:nvSpPr>
+        <p:spPr>
+          <a:xfrm>
+            <a:off x="640080" y="6419088"/>
+            <a:ext cx="10972800" cy="365760"/>
+          </a:xfrm>
+          <a:prstGeom prst="rect">
+            <a:avLst/>
+          </a:prstGeom>
+          <a:noFill/>
+        </p:spPr>
+        <p:txBody>
+          <a:bodyPr wrap="square" anchor="t" lIns="0" rIns="0" tIns="0" bIns="0">
+            <a:spAutoFit/>
+          </a:bodyPr>
+          <a:lstStyle/>
+          <a:p>
+            <a:pPr algn="l">
+              <a:lnSpc>
+                <a:spcPct val="105000"/>
+              </a:lnSpc>
+              <a:spcAft>
+                <a:spcPts val="600"/>
+              </a:spcAft>
+            </a:pPr>
+            <a:r>
+              <a:rPr sz="1050" b="0" i="1">
+                <a:solidFill>
+                  <a:srgbClr val="CADCFC"/>
+                </a:solidFill>
+                <a:latin typeface="Calibri"/>
+              </a:rPr>
+              <a:t>Judging criterion: Demonstration of Model (40%) - handoff to the live demo</a:t>
+            </a:r>
+          </a:p>
+        </p:txBody>
+      </p:sp>
     </p:spTree>
   </p:cSld>
   <p:clrMapOvr>
@@ -5672,7 +6729,7 @@
         </p:nvSpPr>
         <p:spPr>
           <a:xfrm>
-            <a:off x="822960" y="1097280"/>
+            <a:off x="822960" y="640080"/>
             <a:ext cx="10515600" cy="731520"/>
           </a:xfrm>
           <a:prstGeom prst="rect">
@@ -5695,13 +6752,13 @@
               </a:spcAft>
             </a:pPr>
             <a:r>
-              <a:rPr sz="3000" b="1" i="0">
+              <a:rPr sz="3400" b="1" i="0">
                 <a:solidFill>
                   <a:srgbClr val="F2B705"/>
                 </a:solidFill>
                 <a:latin typeface="Georgia"/>
               </a:rPr>
-              <a:t>Original, authentic, reproducible</a:t>
+              <a:t>Questions welcome</a:t>
             </a:r>
           </a:p>
         </p:txBody>
@@ -5714,8 +6771,8 @@
         </p:nvSpPr>
         <p:spPr>
           <a:xfrm>
-            <a:off x="868680" y="2011680"/>
-            <a:ext cx="10424160" cy="1463040"/>
+            <a:off x="868680" y="1600200"/>
+            <a:ext cx="10424160" cy="822960"/>
           </a:xfrm>
           <a:prstGeom prst="rect">
             <a:avLst/>
@@ -5730,64 +6787,63 @@
           <a:p>
             <a:pPr algn="l">
               <a:lnSpc>
-                <a:spcPct val="115000"/>
+                <a:spcPct val="105000"/>
               </a:lnSpc>
               <a:spcAft>
                 <a:spcPts val="600"/>
               </a:spcAft>
             </a:pPr>
             <a:r>
-              <a:rPr sz="1550" b="0" i="0">
+              <a:rPr sz="1900" b="0" i="1">
                 <a:solidFill>
                   <a:srgbClr val="FFFFFF"/>
                 </a:solidFill>
                 <a:latin typeface="Calibri"/>
               </a:rPr>
-              <a:t>Every line of code and every figure is original, written from scratch. Solar and grid carbon are real API data (PVGIS and National Grid ESO); demand is built from real DfT shared-micromobility monitoring data and uses the official UoW Bikes file when provided. Fixed seed, one-command rebuild, passing tests — built for the AI and plagiarism checks.</a:t>
-            </a:r>
-          </a:p>
-        </p:txBody>
-      </p:sp>
-      <p:sp>
-        <p:nvSpPr>
-          <p:cNvPr id="4" name="Rectangle 3"/>
-          <p:cNvSpPr/>
+              <a:t>We turn demand uncertainty from a risk into a design input - and show that robustness pays.</a:t>
+            </a:r>
+          </a:p>
+        </p:txBody>
+      </p:sp>
+      <p:sp>
+        <p:nvSpPr>
+          <p:cNvPr id="4" name="TextBox 3"/>
+          <p:cNvSpPr txBox="1"/>
           <p:nvPr/>
         </p:nvSpPr>
         <p:spPr>
           <a:xfrm>
-            <a:off x="868680" y="3977639"/>
-            <a:ext cx="256032" cy="1097280"/>
+            <a:off x="868680" y="2651760"/>
+            <a:ext cx="3566160" cy="640080"/>
           </a:xfrm>
           <a:prstGeom prst="rect">
             <a:avLst/>
           </a:prstGeom>
-          <a:solidFill>
-            <a:srgbClr val="43AA8B"/>
-          </a:solidFill>
-          <a:ln>
-            <a:noFill/>
-          </a:ln>
-        </p:spPr>
-        <p:style>
-          <a:lnRef idx="1">
-            <a:schemeClr val="accent1"/>
-          </a:lnRef>
-          <a:fillRef idx="3">
-            <a:schemeClr val="accent1"/>
-          </a:fillRef>
-          <a:effectRef idx="2">
-            <a:schemeClr val="accent1"/>
-          </a:effectRef>
-          <a:fontRef idx="minor">
-            <a:schemeClr val="lt1"/>
-          </a:fontRef>
-        </p:style>
-        <p:txBody>
-          <a:bodyPr rtlCol="0" anchor="ctr"/>
-          <a:lstStyle/>
-          <a:p>
-            <a:pPr algn="ctr"/>
+          <a:noFill/>
+        </p:spPr>
+        <p:txBody>
+          <a:bodyPr wrap="square" anchor="t" lIns="0" rIns="0" tIns="0" bIns="0">
+            <a:spAutoFit/>
+          </a:bodyPr>
+          <a:lstStyle/>
+          <a:p>
+            <a:pPr algn="l">
+              <a:lnSpc>
+                <a:spcPct val="105000"/>
+              </a:lnSpc>
+              <a:spcAft>
+                <a:spcPts val="600"/>
+              </a:spcAft>
+            </a:pPr>
+            <a:r>
+              <a:rPr sz="1900" b="1" i="0">
+                <a:solidFill>
+                  <a:srgbClr val="F2B705"/>
+                </a:solidFill>
+                <a:latin typeface="Georgia"/>
+              </a:rPr>
+              <a:t>15 kWp / 0 kWh / 8 bays</a:t>
+            </a:r>
           </a:p>
         </p:txBody>
       </p:sp>
@@ -5799,8 +6855,8 @@
         </p:nvSpPr>
         <p:spPr>
           <a:xfrm>
-            <a:off x="1280160" y="4023360"/>
-            <a:ext cx="10058400" cy="1097280"/>
+            <a:off x="868680" y="3127248"/>
+            <a:ext cx="3566160" cy="731520"/>
           </a:xfrm>
           <a:prstGeom prst="rect">
             <a:avLst/>
@@ -5822,15 +6878,80 @@
               </a:spcAft>
             </a:pPr>
             <a:r>
-              <a:rPr sz="2600" b="1" i="0">
-                <a:solidFill>
-                  <a:srgbClr val="FFFFFF"/>
+              <a:rPr sz="1150" b="0" i="0">
+                <a:solidFill>
+                  <a:srgbClr val="CADCFC"/>
+                </a:solidFill>
+                <a:latin typeface="Calibri"/>
+              </a:rPr>
+              <a:t>recommended robust hub (maximin)</a:t>
+            </a:r>
+          </a:p>
+        </p:txBody>
+      </p:sp>
+      <p:sp>
+        <p:nvSpPr>
+          <p:cNvPr id="6" name="TextBox 5"/>
+          <p:cNvSpPr txBox="1"/>
+          <p:nvPr/>
+        </p:nvSpPr>
+        <p:spPr>
+          <a:xfrm>
+            <a:off x="4709160" y="2651760"/>
+            <a:ext cx="3566160" cy="640080"/>
+          </a:xfrm>
+          <a:prstGeom prst="rect">
+            <a:avLst/>
+          </a:prstGeom>
+          <a:noFill/>
+        </p:spPr>
+        <p:txBody>
+          <a:bodyPr wrap="square" anchor="t" lIns="0" rIns="0" tIns="0" bIns="0">
+            <a:spAutoFit/>
+          </a:bodyPr>
+          <a:lstStyle/>
+          <a:p>
+            <a:pPr algn="l">
+              <a:lnSpc>
+                <a:spcPct val="105000"/>
+              </a:lnSpc>
+              <a:spcAft>
+                <a:spcPts val="600"/>
+              </a:spcAft>
+            </a:pPr>
+            <a:r>
+              <a:rPr sz="1900" b="1" i="0">
+                <a:solidFill>
+                  <a:srgbClr val="F2B705"/>
                 </a:solidFill>
                 <a:latin typeface="Georgia"/>
               </a:rPr>
-              <a:t>We turn demand uncertainty from a risk</a:t>
-            </a:r>
-          </a:p>
+              <a:t>-59%  worst-case cost</a:t>
+            </a:r>
+          </a:p>
+        </p:txBody>
+      </p:sp>
+      <p:sp>
+        <p:nvSpPr>
+          <p:cNvPr id="7" name="TextBox 6"/>
+          <p:cNvSpPr txBox="1"/>
+          <p:nvPr/>
+        </p:nvSpPr>
+        <p:spPr>
+          <a:xfrm>
+            <a:off x="4709160" y="3127248"/>
+            <a:ext cx="3566160" cy="731520"/>
+          </a:xfrm>
+          <a:prstGeom prst="rect">
+            <a:avLst/>
+          </a:prstGeom>
+          <a:noFill/>
+        </p:spPr>
+        <p:txBody>
+          <a:bodyPr wrap="square" anchor="t" lIns="0" rIns="0" tIns="0" bIns="0">
+            <a:spAutoFit/>
+          </a:bodyPr>
+          <a:lstStyle/>
           <a:p>
             <a:pPr algn="l">
               <a:lnSpc>
@@ -5841,27 +6962,27 @@
               </a:spcAft>
             </a:pPr>
             <a:r>
-              <a:rPr sz="2600" b="1" i="0">
-                <a:solidFill>
-                  <a:srgbClr val="F2B705"/>
-                </a:solidFill>
-                <a:latin typeface="Georgia"/>
-              </a:rPr>
-              <a:t>into a design input — and show that robustness pays.</a:t>
-            </a:r>
-          </a:p>
-        </p:txBody>
-      </p:sp>
-      <p:sp>
-        <p:nvSpPr>
-          <p:cNvPr id="6" name="TextBox 5"/>
+              <a:rPr sz="1150" b="0" i="0">
+                <a:solidFill>
+                  <a:srgbClr val="CADCFC"/>
+                </a:solidFill>
+                <a:latin typeface="Calibri"/>
+              </a:rPr>
+              <a:t>GBP 47,179 -&gt; GBP 19,232 per year</a:t>
+            </a:r>
+          </a:p>
+        </p:txBody>
+      </p:sp>
+      <p:sp>
+        <p:nvSpPr>
+          <p:cNvPr id="8" name="TextBox 7"/>
           <p:cNvSpPr txBox="1"/>
           <p:nvPr/>
         </p:nvSpPr>
         <p:spPr>
           <a:xfrm>
-            <a:off x="868680" y="5943600"/>
-            <a:ext cx="10424160" cy="457200"/>
+            <a:off x="8549640" y="2651760"/>
+            <a:ext cx="3566160" cy="640080"/>
           </a:xfrm>
           <a:prstGeom prst="rect">
             <a:avLst/>
@@ -5883,13 +7004,349 @@
               </a:spcAft>
             </a:pPr>
             <a:r>
-              <a:rPr sz="1600" b="0" i="1">
+              <a:rPr sz="1900" b="1" i="0">
+                <a:solidFill>
+                  <a:srgbClr val="F2B705"/>
+                </a:solidFill>
+                <a:latin typeface="Georgia"/>
+              </a:rPr>
+              <a:t>99.6% service</a:t>
+            </a:r>
+          </a:p>
+        </p:txBody>
+      </p:sp>
+      <p:sp>
+        <p:nvSpPr>
+          <p:cNvPr id="9" name="TextBox 8"/>
+          <p:cNvSpPr txBox="1"/>
+          <p:nvPr/>
+        </p:nvSpPr>
+        <p:spPr>
+          <a:xfrm>
+            <a:off x="8549640" y="3127248"/>
+            <a:ext cx="3566160" cy="731520"/>
+          </a:xfrm>
+          <a:prstGeom prst="rect">
+            <a:avLst/>
+          </a:prstGeom>
+          <a:noFill/>
+        </p:spPr>
+        <p:txBody>
+          <a:bodyPr wrap="square" anchor="t" lIns="0" rIns="0" tIns="0" bIns="0">
+            <a:spAutoFit/>
+          </a:bodyPr>
+          <a:lstStyle/>
+          <a:p>
+            <a:pPr algn="l">
+              <a:lnSpc>
+                <a:spcPct val="110000"/>
+              </a:lnSpc>
+              <a:spcAft>
+                <a:spcPts val="600"/>
+              </a:spcAft>
+            </a:pPr>
+            <a:r>
+              <a:rPr sz="1150" b="0" i="0">
                 <a:solidFill>
                   <a:srgbClr val="CADCFC"/>
                 </a:solidFill>
                 <a:latin typeface="Calibri"/>
               </a:rPr>
-              <a:t>Thank you.</a:t>
+              <a:t>guaranteed in every one of 15 futures</a:t>
+            </a:r>
+          </a:p>
+        </p:txBody>
+      </p:sp>
+      <p:sp>
+        <p:nvSpPr>
+          <p:cNvPr id="10" name="TextBox 9"/>
+          <p:cNvSpPr txBox="1"/>
+          <p:nvPr/>
+        </p:nvSpPr>
+        <p:spPr>
+          <a:xfrm>
+            <a:off x="868680" y="4297680"/>
+            <a:ext cx="3566160" cy="640080"/>
+          </a:xfrm>
+          <a:prstGeom prst="rect">
+            <a:avLst/>
+          </a:prstGeom>
+          <a:noFill/>
+        </p:spPr>
+        <p:txBody>
+          <a:bodyPr wrap="square" anchor="t" lIns="0" rIns="0" tIns="0" bIns="0">
+            <a:spAutoFit/>
+          </a:bodyPr>
+          <a:lstStyle/>
+          <a:p>
+            <a:pPr algn="l">
+              <a:lnSpc>
+                <a:spcPct val="105000"/>
+              </a:lnSpc>
+              <a:spcAft>
+                <a:spcPts val="600"/>
+              </a:spcAft>
+            </a:pPr>
+            <a:r>
+              <a:rPr sz="1900" b="1" i="0">
+                <a:solidFill>
+                  <a:srgbClr val="F2B705"/>
+                </a:solidFill>
+                <a:latin typeface="Georgia"/>
+              </a:rPr>
+              <a:t>battery only if grid &lt;= 9 kW</a:t>
+            </a:r>
+          </a:p>
+        </p:txBody>
+      </p:sp>
+      <p:sp>
+        <p:nvSpPr>
+          <p:cNvPr id="11" name="TextBox 10"/>
+          <p:cNvSpPr txBox="1"/>
+          <p:nvPr/>
+        </p:nvSpPr>
+        <p:spPr>
+          <a:xfrm>
+            <a:off x="868680" y="4773168"/>
+            <a:ext cx="3566160" cy="731520"/>
+          </a:xfrm>
+          <a:prstGeom prst="rect">
+            <a:avLst/>
+          </a:prstGeom>
+          <a:noFill/>
+        </p:spPr>
+        <p:txBody>
+          <a:bodyPr wrap="square" anchor="t" lIns="0" rIns="0" tIns="0" bIns="0">
+            <a:spAutoFit/>
+          </a:bodyPr>
+          <a:lstStyle/>
+          <a:p>
+            <a:pPr algn="l">
+              <a:lnSpc>
+                <a:spcPct val="110000"/>
+              </a:lnSpc>
+              <a:spcAft>
+                <a:spcPts val="600"/>
+              </a:spcAft>
+            </a:pPr>
+            <a:r>
+              <a:rPr sz="1150" b="0" i="0">
+                <a:solidFill>
+                  <a:srgbClr val="CADCFC"/>
+                </a:solidFill>
+                <a:latin typeface="Calibri"/>
+              </a:rPr>
+              <a:t>the storage boundary, located by sweep</a:t>
+            </a:r>
+          </a:p>
+        </p:txBody>
+      </p:sp>
+      <p:sp>
+        <p:nvSpPr>
+          <p:cNvPr id="12" name="TextBox 11"/>
+          <p:cNvSpPr txBox="1"/>
+          <p:nvPr/>
+        </p:nvSpPr>
+        <p:spPr>
+          <a:xfrm>
+            <a:off x="4709160" y="4297680"/>
+            <a:ext cx="3566160" cy="640080"/>
+          </a:xfrm>
+          <a:prstGeom prst="rect">
+            <a:avLst/>
+          </a:prstGeom>
+          <a:noFill/>
+        </p:spPr>
+        <p:txBody>
+          <a:bodyPr wrap="square" anchor="t" lIns="0" rIns="0" tIns="0" bIns="0">
+            <a:spAutoFit/>
+          </a:bodyPr>
+          <a:lstStyle/>
+          <a:p>
+            <a:pPr algn="l">
+              <a:lnSpc>
+                <a:spcPct val="105000"/>
+              </a:lnSpc>
+              <a:spcAft>
+                <a:spcPts val="600"/>
+              </a:spcAft>
+            </a:pPr>
+            <a:r>
+              <a:rPr sz="1900" b="1" i="0">
+                <a:solidFill>
+                  <a:srgbClr val="F2B705"/>
+                </a:solidFill>
+                <a:latin typeface="Georgia"/>
+              </a:rPr>
+              <a:t>9/9 validated</a:t>
+            </a:r>
+          </a:p>
+        </p:txBody>
+      </p:sp>
+      <p:sp>
+        <p:nvSpPr>
+          <p:cNvPr id="13" name="TextBox 12"/>
+          <p:cNvSpPr txBox="1"/>
+          <p:nvPr/>
+        </p:nvSpPr>
+        <p:spPr>
+          <a:xfrm>
+            <a:off x="4709160" y="4773168"/>
+            <a:ext cx="3566160" cy="731520"/>
+          </a:xfrm>
+          <a:prstGeom prst="rect">
+            <a:avLst/>
+          </a:prstGeom>
+          <a:noFill/>
+        </p:spPr>
+        <p:txBody>
+          <a:bodyPr wrap="square" anchor="t" lIns="0" rIns="0" tIns="0" bIns="0">
+            <a:spAutoFit/>
+          </a:bodyPr>
+          <a:lstStyle/>
+          <a:p>
+            <a:pPr algn="l">
+              <a:lnSpc>
+                <a:spcPct val="110000"/>
+              </a:lnSpc>
+              <a:spcAft>
+                <a:spcPts val="600"/>
+              </a:spcAft>
+            </a:pPr>
+            <a:r>
+              <a:rPr sz="1150" b="0" i="0">
+                <a:solidFill>
+                  <a:srgbClr val="CADCFC"/>
+                </a:solidFill>
+                <a:latin typeface="Calibri"/>
+              </a:rPr>
+              <a:t>outputs &amp; inputs within published ranges</a:t>
+            </a:r>
+          </a:p>
+        </p:txBody>
+      </p:sp>
+      <p:sp>
+        <p:nvSpPr>
+          <p:cNvPr id="14" name="TextBox 13"/>
+          <p:cNvSpPr txBox="1"/>
+          <p:nvPr/>
+        </p:nvSpPr>
+        <p:spPr>
+          <a:xfrm>
+            <a:off x="8549640" y="4297680"/>
+            <a:ext cx="3566160" cy="640080"/>
+          </a:xfrm>
+          <a:prstGeom prst="rect">
+            <a:avLst/>
+          </a:prstGeom>
+          <a:noFill/>
+        </p:spPr>
+        <p:txBody>
+          <a:bodyPr wrap="square" anchor="t" lIns="0" rIns="0" tIns="0" bIns="0">
+            <a:spAutoFit/>
+          </a:bodyPr>
+          <a:lstStyle/>
+          <a:p>
+            <a:pPr algn="l">
+              <a:lnSpc>
+                <a:spcPct val="105000"/>
+              </a:lnSpc>
+              <a:spcAft>
+                <a:spcPts val="600"/>
+              </a:spcAft>
+            </a:pPr>
+            <a:r>
+              <a:rPr sz="1900" b="1" i="0">
+                <a:solidFill>
+                  <a:srgbClr val="F2B705"/>
+                </a:solidFill>
+                <a:latin typeface="Georgia"/>
+              </a:rPr>
+              <a:t>3.7 tCO2/yr avoided</a:t>
+            </a:r>
+          </a:p>
+        </p:txBody>
+      </p:sp>
+      <p:sp>
+        <p:nvSpPr>
+          <p:cNvPr id="15" name="TextBox 14"/>
+          <p:cNvSpPr txBox="1"/>
+          <p:nvPr/>
+        </p:nvSpPr>
+        <p:spPr>
+          <a:xfrm>
+            <a:off x="8549640" y="4773168"/>
+            <a:ext cx="3566160" cy="731520"/>
+          </a:xfrm>
+          <a:prstGeom prst="rect">
+            <a:avLst/>
+          </a:prstGeom>
+          <a:noFill/>
+        </p:spPr>
+        <p:txBody>
+          <a:bodyPr wrap="square" anchor="t" lIns="0" rIns="0" tIns="0" bIns="0">
+            <a:spAutoFit/>
+          </a:bodyPr>
+          <a:lstStyle/>
+          <a:p>
+            <a:pPr algn="l">
+              <a:lnSpc>
+                <a:spcPct val="110000"/>
+              </a:lnSpc>
+              <a:spcAft>
+                <a:spcPts val="600"/>
+              </a:spcAft>
+            </a:pPr>
+            <a:r>
+              <a:rPr sz="1150" b="0" i="0">
+                <a:solidFill>
+                  <a:srgbClr val="CADCFC"/>
+                </a:solidFill>
+                <a:latin typeface="Calibri"/>
+              </a:rPr>
+              <a:t>15% vs grid-only, marginal basis</a:t>
+            </a:r>
+          </a:p>
+        </p:txBody>
+      </p:sp>
+      <p:sp>
+        <p:nvSpPr>
+          <p:cNvPr id="16" name="TextBox 15"/>
+          <p:cNvSpPr txBox="1"/>
+          <p:nvPr/>
+        </p:nvSpPr>
+        <p:spPr>
+          <a:xfrm>
+            <a:off x="868680" y="5943600"/>
+            <a:ext cx="10424160" cy="457200"/>
+          </a:xfrm>
+          <a:prstGeom prst="rect">
+            <a:avLst/>
+          </a:prstGeom>
+          <a:noFill/>
+        </p:spPr>
+        <p:txBody>
+          <a:bodyPr wrap="square" anchor="t" lIns="0" rIns="0" tIns="0" bIns="0">
+            <a:spAutoFit/>
+          </a:bodyPr>
+          <a:lstStyle/>
+          <a:p>
+            <a:pPr algn="l">
+              <a:lnSpc>
+                <a:spcPct val="105000"/>
+              </a:lnSpc>
+              <a:spcAft>
+                <a:spcPts val="600"/>
+              </a:spcAft>
+            </a:pPr>
+            <a:r>
+              <a:rPr sz="1200" b="0" i="0">
+                <a:solidFill>
+                  <a:srgbClr val="FFFFFF"/>
+                </a:solidFill>
+                <a:latin typeface="Calibri"/>
+              </a:rPr>
+              <a:t>Live demo: gourav88502.github.io/emicromobility-robust-charging    -    Code, data &amp; tests: github.com/Gourav88502/emicromobility-robust-charging  (MIT, one-command reproducible)</a:t>
             </a:r>
           </a:p>
         </p:txBody>

</xml_diff>

<commit_message>
Fix slide-5 threshold strip: read battery values from grid_battery_threshold.csv instead of stale hardcoded list (8 kW is 50 kWh, not 20)
Co-Authored-By: Claude Fable 5 <noreply@anthropic.com>
</commit_message>
<xml_diff>
--- a/outputs/Presentation.pptx
+++ b/outputs/Presentation.pptx
@@ -5765,7 +5765,7 @@
                 </a:solidFill>
                 <a:latin typeface="Calibri"/>
               </a:rPr>
-              <a:t>50</a:t>
+              <a:t>50.0</a:t>
             </a:r>
           </a:p>
         </p:txBody>
@@ -5807,7 +5807,7 @@
                 </a:solidFill>
                 <a:latin typeface="Calibri"/>
               </a:rPr>
-              <a:t>4</a:t>
+              <a:t>4.0</a:t>
             </a:r>
           </a:p>
         </p:txBody>
@@ -5892,7 +5892,7 @@
                 </a:solidFill>
                 <a:latin typeface="Calibri"/>
               </a:rPr>
-              <a:t>50</a:t>
+              <a:t>50.0</a:t>
             </a:r>
           </a:p>
         </p:txBody>
@@ -5934,7 +5934,7 @@
                 </a:solidFill>
                 <a:latin typeface="Calibri"/>
               </a:rPr>
-              <a:t>6</a:t>
+              <a:t>6.0</a:t>
             </a:r>
           </a:p>
         </p:txBody>
@@ -5947,8 +5947,8 @@
         </p:nvSpPr>
         <p:spPr>
           <a:xfrm>
-            <a:off x="2468880" y="3319272"/>
-            <a:ext cx="566928" cy="841247"/>
+            <a:off x="2468880" y="2057400"/>
+            <a:ext cx="566928" cy="2103120"/>
           </a:xfrm>
           <a:prstGeom prst="roundRect">
             <a:avLst/>
@@ -5990,7 +5990,7 @@
         </p:nvSpPr>
         <p:spPr>
           <a:xfrm>
-            <a:off x="2395728" y="3008376"/>
+            <a:off x="2395728" y="1746504"/>
             <a:ext cx="749808" cy="274320"/>
           </a:xfrm>
           <a:prstGeom prst="rect">
@@ -6019,7 +6019,7 @@
                 </a:solidFill>
                 <a:latin typeface="Calibri"/>
               </a:rPr>
-              <a:t>20</a:t>
+              <a:t>50.0</a:t>
             </a:r>
           </a:p>
         </p:txBody>
@@ -6061,7 +6061,7 @@
                 </a:solidFill>
                 <a:latin typeface="Calibri"/>
               </a:rPr>
-              <a:t>8</a:t>
+              <a:t>8.0</a:t>
             </a:r>
           </a:p>
         </p:txBody>
@@ -6146,7 +6146,7 @@
                 </a:solidFill>
                 <a:latin typeface="Calibri"/>
               </a:rPr>
-              <a:t>10</a:t>
+              <a:t>10.0</a:t>
             </a:r>
           </a:p>
         </p:txBody>
@@ -6231,7 +6231,7 @@
                 </a:solidFill>
                 <a:latin typeface="Calibri"/>
               </a:rPr>
-              <a:t>12</a:t>
+              <a:t>12.0</a:t>
             </a:r>
           </a:p>
         </p:txBody>
@@ -6316,7 +6316,7 @@
                 </a:solidFill>
                 <a:latin typeface="Calibri"/>
               </a:rPr>
-              <a:t>15</a:t>
+              <a:t>15.0</a:t>
             </a:r>
           </a:p>
         </p:txBody>
@@ -6401,7 +6401,7 @@
                 </a:solidFill>
                 <a:latin typeface="Calibri"/>
               </a:rPr>
-              <a:t>18</a:t>
+              <a:t>18.0</a:t>
             </a:r>
           </a:p>
         </p:txBody>
@@ -6486,7 +6486,7 @@
                 </a:solidFill>
                 <a:latin typeface="Calibri"/>
               </a:rPr>
-              <a:t>20</a:t>
+              <a:t>20.0</a:t>
             </a:r>
           </a:p>
         </p:txBody>

</xml_diff>